<commit_message>
docs: revise checkpoint PPT with integration/trigger/storage focus
White background, red titles, Microsoft YaHei font. Content restructured
into three sections: plugin integration, trigger mechanism, and storage.

https://claude.ai/code/session_01M8cf6pZ6TEU8qPCRsY1mHo
</commit_message>
<xml_diff>
--- a/checkpoint-overview.pptx
+++ b/checkpoint-overview.pptx
@@ -3084,7 +3084,7 @@
     <p:bg>
       <p:bgPr>
         <a:solidFill>
-          <a:srgbClr val="1A1A2E"/>
+          <a:srgbClr val="FFFFFF"/>
         </a:solidFill>
         <a:effectLst/>
       </p:bgPr>
@@ -3105,13 +3105,13 @@
         <p:spPr>
           <a:xfrm>
             <a:off x="0" y="0"/>
-            <a:ext cx="12191695" cy="868680"/>
+            <a:ext cx="12191695" cy="777240"/>
           </a:xfrm>
           <a:prstGeom prst="rect">
             <a:avLst/>
           </a:prstGeom>
           <a:solidFill>
-            <a:srgbClr val="161628"/>
+            <a:srgbClr val="F5F5F5"/>
           </a:solidFill>
           <a:ln>
             <a:noFill/>
@@ -3148,8 +3148,8 @@
         </p:nvSpPr>
         <p:spPr>
           <a:xfrm>
-            <a:off x="548640" y="137160"/>
-            <a:ext cx="9144000" cy="594360"/>
+            <a:off x="457200" y="137160"/>
+            <a:ext cx="7315200" cy="548640"/>
           </a:xfrm>
           <a:prstGeom prst="rect">
             <a:avLst/>
@@ -3163,14 +3163,15 @@
           <a:lstStyle/>
           <a:p>
             <a:pPr algn="l">
-              <a:defRPr sz="2800" b="1">
-                <a:solidFill>
-                  <a:srgbClr val="00D2FF"/>
-                </a:solidFill>
-              </a:defRPr>
-            </a:pPr>
-            <a:r>
-              <a:t>Workspace Checkpoint &amp; Rollback Plugin</a:t>
+              <a:defRPr sz="2400" b="1">
+                <a:solidFill>
+                  <a:srgbClr val="C81E1E"/>
+                </a:solidFill>
+                <a:latin typeface="Microsoft YaHei"/>
+              </a:defRPr>
+            </a:pPr>
+            <a:r>
+              <a:t>OpenClaw Checkpoint 插件方案</a:t>
             </a:r>
           </a:p>
         </p:txBody>
@@ -3183,8 +3184,8 @@
         </p:nvSpPr>
         <p:spPr>
           <a:xfrm>
-            <a:off x="7772400" y="228600"/>
-            <a:ext cx="4114800" cy="457200"/>
+            <a:off x="7772400" y="201168"/>
+            <a:ext cx="4114800" cy="411480"/>
           </a:xfrm>
           <a:prstGeom prst="rect">
             <a:avLst/>
@@ -3198,14 +3199,15 @@
           <a:lstStyle/>
           <a:p>
             <a:pPr algn="r">
-              <a:defRPr sz="1400" b="0">
-                <a:solidFill>
-                  <a:srgbClr val="CCCCDD"/>
-                </a:solidFill>
-              </a:defRPr>
-            </a:pPr>
-            <a:r>
-              <a:t>基于 git commit-tree 的轻量级工作区快照方案</a:t>
+              <a:defRPr sz="1300" b="0">
+                <a:solidFill>
+                  <a:srgbClr val="444444"/>
+                </a:solidFill>
+                <a:latin typeface="Microsoft YaHei"/>
+              </a:defRPr>
+            </a:pPr>
+            <a:r>
+              <a:t>基于 git commit-tree 的工作区快照与回滚</a:t>
             </a:r>
           </a:p>
         </p:txBody>
@@ -3218,14 +3220,14 @@
         </p:nvSpPr>
         <p:spPr>
           <a:xfrm>
-            <a:off x="365760" y="1097280"/>
-            <a:ext cx="3749039" cy="2651760"/>
+            <a:off x="457200" y="804672"/>
+            <a:ext cx="11338560" cy="27432"/>
           </a:xfrm>
           <a:prstGeom prst="rect">
             <a:avLst/>
           </a:prstGeom>
           <a:solidFill>
-            <a:srgbClr val="24243E"/>
+            <a:srgbClr val="C81E1E"/>
           </a:solidFill>
           <a:ln>
             <a:noFill/>
@@ -3256,204 +3258,20 @@
       </p:sp>
       <p:sp>
         <p:nvSpPr>
-          <p:cNvPr id="6" name="TextBox 5"/>
-          <p:cNvSpPr txBox="1"/>
+          <p:cNvPr id="6" name="Rectangle 5"/>
+          <p:cNvSpPr/>
           <p:nvPr/>
         </p:nvSpPr>
         <p:spPr>
           <a:xfrm>
-            <a:off x="548640" y="1188720"/>
-            <a:ext cx="3383280" cy="365760"/>
-          </a:xfrm>
-          <a:prstGeom prst="rect">
-            <a:avLst/>
-          </a:prstGeom>
-          <a:noFill/>
-        </p:spPr>
-        <p:txBody>
-          <a:bodyPr wrap="square">
-            <a:spAutoFit/>
-          </a:bodyPr>
-          <a:lstStyle/>
-          <a:p>
-            <a:pPr algn="l">
-              <a:defRPr sz="1800" b="1">
-                <a:solidFill>
-                  <a:srgbClr val="00D2FF"/>
-                </a:solidFill>
-              </a:defRPr>
-            </a:pPr>
-            <a:r>
-              <a:t>核心原理</a:t>
-            </a:r>
-          </a:p>
-        </p:txBody>
-      </p:sp>
-      <p:sp>
-        <p:nvSpPr>
-          <p:cNvPr id="7" name="TextBox 6"/>
-          <p:cNvSpPr txBox="1"/>
-          <p:nvPr/>
-        </p:nvSpPr>
-        <p:spPr>
-          <a:xfrm>
-            <a:off x="548640" y="1600200"/>
-            <a:ext cx="3383280" cy="2011680"/>
-          </a:xfrm>
-          <a:prstGeom prst="rect">
-            <a:avLst/>
-          </a:prstGeom>
-          <a:noFill/>
-        </p:spPr>
-        <p:txBody>
-          <a:bodyPr wrap="square">
-            <a:spAutoFit/>
-          </a:bodyPr>
-          <a:lstStyle/>
-          <a:p>
-            <a:pPr algn="l">
-              <a:defRPr sz="1200" b="0">
-                <a:solidFill>
-                  <a:srgbClr val="CCCCDD"/>
-                </a:solidFill>
-              </a:defRPr>
-            </a:pPr>
-          </a:p>
-          <a:p>
-            <a:pPr>
-              <a:spcBef>
-                <a:spcPts val="200"/>
-              </a:spcBef>
-              <a:defRPr sz="1200" b="1">
-                <a:solidFill>
-                  <a:srgbClr val="FFFFFF"/>
-                </a:solidFill>
-              </a:defRPr>
-            </a:pPr>
-            <a:r>
-              <a:t>使用 git commit-tree 创建游离提交(detached commit)</a:t>
-            </a:r>
-          </a:p>
-          <a:p>
-            <a:pPr>
-              <a:spcBef>
-                <a:spcPts val="400"/>
-              </a:spcBef>
-              <a:defRPr sz="1100" b="0">
-                <a:solidFill>
-                  <a:srgbClr val="CCCCDD"/>
-                </a:solidFill>
-              </a:defRPr>
-            </a:pPr>
-            <a:r>
-              <a:t>• 不挂载到任何分支，不影响 HEAD</a:t>
-            </a:r>
-          </a:p>
-          <a:p>
-            <a:pPr>
-              <a:spcBef>
-                <a:spcPts val="400"/>
-              </a:spcBef>
-              <a:defRPr sz="1100" b="0">
-                <a:solidFill>
-                  <a:srgbClr val="CCCCDD"/>
-                </a:solidFill>
-              </a:defRPr>
-            </a:pPr>
-            <a:r>
-              <a:t>• 每次工具调用后自动创建快照</a:t>
-            </a:r>
-          </a:p>
-          <a:p>
-            <a:pPr>
-              <a:spcBef>
-                <a:spcPts val="400"/>
-              </a:spcBef>
-              <a:defRPr sz="1100" b="0">
-                <a:solidFill>
-                  <a:srgbClr val="CCCCDD"/>
-                </a:solidFill>
-              </a:defRPr>
-            </a:pPr>
-            <a:r>
-              <a:t>• 通过 -p 参数串联父子链</a:t>
-            </a:r>
-          </a:p>
-          <a:p>
-            <a:pPr>
-              <a:spcBef>
-                <a:spcPts val="400"/>
-              </a:spcBef>
-              <a:defRPr sz="600" b="0">
-                <a:solidFill>
-                  <a:srgbClr val="CCCCDD"/>
-                </a:solidFill>
-              </a:defRPr>
-            </a:pPr>
-          </a:p>
-          <a:p>
-            <a:pPr>
-              <a:spcBef>
-                <a:spcPts val="400"/>
-              </a:spcBef>
-              <a:defRPr sz="1200" b="1">
-                <a:solidFill>
-                  <a:srgbClr val="00E696"/>
-                </a:solidFill>
-              </a:defRPr>
-            </a:pPr>
-            <a:r>
-              <a:t>双重状态追踪</a:t>
-            </a:r>
-          </a:p>
-          <a:p>
-            <a:pPr>
-              <a:spcBef>
-                <a:spcPts val="400"/>
-              </a:spcBef>
-              <a:defRPr sz="1100" b="0">
-                <a:solidFill>
-                  <a:srgbClr val="CCCCDD"/>
-                </a:solidFill>
-              </a:defRPr>
-            </a:pPr>
-            <a:r>
-              <a:t>• 文件状态 → git tree/commit SHA</a:t>
-            </a:r>
-          </a:p>
-          <a:p>
-            <a:pPr>
-              <a:spcBef>
-                <a:spcPts val="400"/>
-              </a:spcBef>
-              <a:defRPr sz="1100" b="0">
-                <a:solidFill>
-                  <a:srgbClr val="CCCCDD"/>
-                </a:solidFill>
-              </a:defRPr>
-            </a:pPr>
-            <a:r>
-              <a:t>• 对话历史 → JSONL 字节偏移量</a:t>
-            </a:r>
-          </a:p>
-        </p:txBody>
-      </p:sp>
-      <p:sp>
-        <p:nvSpPr>
-          <p:cNvPr id="8" name="Rectangle 7"/>
-          <p:cNvSpPr/>
-          <p:nvPr/>
-        </p:nvSpPr>
-        <p:spPr>
-          <a:xfrm>
-            <a:off x="4297680" y="1097280"/>
-            <a:ext cx="3931920" cy="2651760"/>
+            <a:off x="365760" y="1051560"/>
+            <a:ext cx="3611880" cy="5303520"/>
           </a:xfrm>
           <a:prstGeom prst="rect">
             <a:avLst/>
           </a:prstGeom>
           <a:solidFill>
-            <a:srgbClr val="24243E"/>
+            <a:srgbClr val="F5F5F5"/>
           </a:solidFill>
           <a:ln>
             <a:noFill/>
@@ -3484,14 +3302,14 @@
       </p:sp>
       <p:sp>
         <p:nvSpPr>
-          <p:cNvPr id="9" name="TextBox 8"/>
+          <p:cNvPr id="7" name="TextBox 6"/>
           <p:cNvSpPr txBox="1"/>
           <p:nvPr/>
         </p:nvSpPr>
         <p:spPr>
           <a:xfrm>
-            <a:off x="4480560" y="1188720"/>
-            <a:ext cx="3566160" cy="365760"/>
+            <a:off x="502920" y="1143000"/>
+            <a:ext cx="3291840" cy="365760"/>
           </a:xfrm>
           <a:prstGeom prst="rect">
             <a:avLst/>
@@ -3505,28 +3323,29 @@
           <a:lstStyle/>
           <a:p>
             <a:pPr algn="l">
-              <a:defRPr sz="1800" b="1">
-                <a:solidFill>
-                  <a:srgbClr val="00D2FF"/>
-                </a:solidFill>
-              </a:defRPr>
-            </a:pPr>
-            <a:r>
-              <a:t>创建 &amp; 回滚流程</a:t>
-            </a:r>
-          </a:p>
-        </p:txBody>
-      </p:sp>
-      <p:sp>
-        <p:nvSpPr>
-          <p:cNvPr id="10" name="TextBox 9"/>
+              <a:defRPr sz="2400" b="1">
+                <a:solidFill>
+                  <a:srgbClr val="C81E1E"/>
+                </a:solidFill>
+                <a:latin typeface="Microsoft YaHei"/>
+              </a:defRPr>
+            </a:pPr>
+            <a:r>
+              <a:t>一、插件集成</a:t>
+            </a:r>
+          </a:p>
+        </p:txBody>
+      </p:sp>
+      <p:sp>
+        <p:nvSpPr>
+          <p:cNvPr id="8" name="TextBox 7"/>
           <p:cNvSpPr txBox="1"/>
           <p:nvPr/>
         </p:nvSpPr>
         <p:spPr>
           <a:xfrm>
-            <a:off x="4480560" y="1600200"/>
-            <a:ext cx="3566160" cy="1097280"/>
+            <a:off x="502920" y="1554480"/>
+            <a:ext cx="3291840" cy="320040"/>
           </a:xfrm>
           <a:prstGeom prst="rect">
             <a:avLst/>
@@ -3540,193 +3359,269 @@
           <a:lstStyle/>
           <a:p>
             <a:pPr algn="l">
+              <a:defRPr sz="1200" b="1">
+                <a:solidFill>
+                  <a:srgbClr val="444444"/>
+                </a:solidFill>
+                <a:latin typeface="Microsoft YaHei"/>
+              </a:defRPr>
+            </a:pPr>
+            <a:r>
+              <a:t>注册方式</a:t>
+            </a:r>
+          </a:p>
+          <a:p>
+            <a:pPr>
+              <a:spcBef>
+                <a:spcPts val="300"/>
+              </a:spcBef>
               <a:defRPr sz="1200" b="0">
                 <a:solidFill>
-                  <a:srgbClr val="FFFFFF"/>
-                </a:solidFill>
-              </a:defRPr>
-            </a:pPr>
-          </a:p>
-          <a:p>
-            <a:pPr>
-              <a:spcBef>
-                <a:spcPts val="200"/>
+                  <a:srgbClr val="222222"/>
+                </a:solidFill>
+                <a:latin typeface="Microsoft YaHei"/>
+              </a:defRPr>
+            </a:pPr>
+            <a:r>
+              <a:t>通过 OpenClaw 插件系统注册（extensions/checkpoint/）</a:t>
+            </a:r>
+          </a:p>
+          <a:p>
+            <a:pPr>
+              <a:spcBef>
+                <a:spcPts val="300"/>
+              </a:spcBef>
+              <a:defRPr sz="1200" b="0">
+                <a:solidFill>
+                  <a:srgbClr val="222222"/>
+                </a:solidFill>
+                <a:latin typeface="Microsoft YaHei"/>
+              </a:defRPr>
+            </a:pPr>
+            <a:r>
+              <a:t>条件加载：仅在 config.enabled === true 时注册</a:t>
+            </a:r>
+          </a:p>
+          <a:p>
+            <a:pPr>
+              <a:spcBef>
+                <a:spcPts val="300"/>
+              </a:spcBef>
+              <a:defRPr sz="600" b="0">
+                <a:solidFill>
+                  <a:srgbClr val="222222"/>
+                </a:solidFill>
+                <a:latin typeface="Microsoft YaHei"/>
+              </a:defRPr>
+            </a:pPr>
+          </a:p>
+          <a:p>
+            <a:pPr>
+              <a:spcBef>
+                <a:spcPts val="300"/>
               </a:spcBef>
               <a:defRPr sz="1200" b="1">
                 <a:solidFill>
-                  <a:srgbClr val="00E696"/>
-                </a:solidFill>
-              </a:defRPr>
-            </a:pPr>
-            <a:r>
-              <a:t>创建 Checkpoint</a:t>
-            </a:r>
-          </a:p>
-          <a:p>
-            <a:pPr>
-              <a:spcBef>
-                <a:spcPts val="400"/>
-              </a:spcBef>
-              <a:defRPr sz="1100" b="1">
-                <a:solidFill>
-                  <a:srgbClr val="FF9F43"/>
-                </a:solidFill>
-              </a:defRPr>
-            </a:pPr>
-            <a:r>
-              <a:t>git add -A</a:t>
-            </a:r>
-          </a:p>
-          <a:p>
-            <a:pPr>
-              <a:spcBef>
-                <a:spcPts val="400"/>
-              </a:spcBef>
-              <a:defRPr sz="1000" b="0">
-                <a:solidFill>
-                  <a:srgbClr val="CCCCDD"/>
-                </a:solidFill>
-              </a:defRPr>
-            </a:pPr>
-            <a:r>
-              <a:t>  → git write-tree          (生成 tree SHA)</a:t>
-            </a:r>
-          </a:p>
-          <a:p>
-            <a:pPr>
-              <a:spcBef>
-                <a:spcPts val="400"/>
-              </a:spcBef>
-              <a:defRPr sz="1000" b="0">
-                <a:solidFill>
-                  <a:srgbClr val="CCCCDD"/>
-                </a:solidFill>
-              </a:defRPr>
-            </a:pPr>
-            <a:r>
-              <a:t>  → git commit-tree -p ...   (游离 commit)</a:t>
-            </a:r>
-          </a:p>
-          <a:p>
-            <a:pPr>
-              <a:spcBef>
-                <a:spcPts val="400"/>
-              </a:spcBef>
-              <a:defRPr sz="1000" b="0">
-                <a:solidFill>
-                  <a:srgbClr val="CCCCDD"/>
-                </a:solidFill>
-              </a:defRPr>
-            </a:pPr>
-            <a:r>
-              <a:t>  → git reset               (恢复索引)</a:t>
-            </a:r>
-          </a:p>
-          <a:p>
-            <a:pPr>
-              <a:spcBef>
-                <a:spcPts val="400"/>
+                  <a:srgbClr val="444444"/>
+                </a:solidFill>
+                <a:latin typeface="Microsoft YaHei"/>
+              </a:defRPr>
+            </a:pPr>
+            <a:r>
+              <a:t>三个注册点</a:t>
+            </a:r>
+          </a:p>
+          <a:p>
+            <a:pPr>
+              <a:spcBef>
+                <a:spcPts val="300"/>
+              </a:spcBef>
+              <a:defRPr sz="1200" b="0">
+                <a:solidFill>
+                  <a:srgbClr val="222222"/>
+                </a:solidFill>
+                <a:latin typeface="Microsoft YaHei"/>
+              </a:defRPr>
+            </a:pPr>
+            <a:r>
+              <a:t>1. Hooks —— 接入 agent 生命周期事件</a:t>
+            </a:r>
+          </a:p>
+          <a:p>
+            <a:pPr>
+              <a:spcBef>
+                <a:spcPts val="300"/>
+              </a:spcBef>
+              <a:defRPr sz="1200" b="0">
+                <a:solidFill>
+                  <a:srgbClr val="222222"/>
+                </a:solidFill>
+                <a:latin typeface="Microsoft YaHei"/>
+              </a:defRPr>
+            </a:pPr>
+            <a:r>
+              <a:t>    after_tool_call：工具调用完成后</a:t>
+            </a:r>
+          </a:p>
+          <a:p>
+            <a:pPr>
+              <a:spcBef>
+                <a:spcPts val="300"/>
+              </a:spcBef>
+              <a:defRPr sz="1200" b="0">
+                <a:solidFill>
+                  <a:srgbClr val="222222"/>
+                </a:solidFill>
+                <a:latin typeface="Microsoft YaHei"/>
+              </a:defRPr>
+            </a:pPr>
+            <a:r>
+              <a:t>    session_start：会话启动时</a:t>
+            </a:r>
+          </a:p>
+          <a:p>
+            <a:pPr>
+              <a:spcBef>
+                <a:spcPts val="300"/>
+              </a:spcBef>
+              <a:defRPr sz="1200" b="0">
+                <a:solidFill>
+                  <a:srgbClr val="222222"/>
+                </a:solidFill>
+                <a:latin typeface="Microsoft YaHei"/>
+              </a:defRPr>
+            </a:pPr>
+            <a:r>
+              <a:t>2. Tool —— 注册 Agent 可调用工具</a:t>
+            </a:r>
+          </a:p>
+          <a:p>
+            <a:pPr>
+              <a:spcBef>
+                <a:spcPts val="300"/>
+              </a:spcBef>
+              <a:defRPr sz="1200" b="0">
+                <a:solidFill>
+                  <a:srgbClr val="222222"/>
+                </a:solidFill>
+                <a:latin typeface="Microsoft YaHei"/>
+              </a:defRPr>
+            </a:pPr>
+            <a:r>
+              <a:t>    支持 list / create / restore 三个操作</a:t>
+            </a:r>
+          </a:p>
+          <a:p>
+            <a:pPr>
+              <a:spcBef>
+                <a:spcPts val="300"/>
+              </a:spcBef>
+              <a:defRPr sz="1200" b="0">
+                <a:solidFill>
+                  <a:srgbClr val="222222"/>
+                </a:solidFill>
+                <a:latin typeface="Microsoft YaHei"/>
+              </a:defRPr>
+            </a:pPr>
+            <a:r>
+              <a:t>3. HTTP Routes —— 注册可视化端点</a:t>
+            </a:r>
+          </a:p>
+          <a:p>
+            <a:pPr>
+              <a:spcBef>
+                <a:spcPts val="300"/>
+              </a:spcBef>
+              <a:defRPr sz="1200" b="0">
+                <a:solidFill>
+                  <a:srgbClr val="222222"/>
+                </a:solidFill>
+                <a:latin typeface="Microsoft YaHei"/>
+              </a:defRPr>
+            </a:pPr>
+            <a:r>
+              <a:t>    /plugins/checkpoint/ 提供时间线 UI</a:t>
+            </a:r>
+          </a:p>
+          <a:p>
+            <a:pPr>
+              <a:spcBef>
+                <a:spcPts val="300"/>
               </a:spcBef>
               <a:defRPr sz="600" b="0">
                 <a:solidFill>
-                  <a:srgbClr val="CCCCDD"/>
-                </a:solidFill>
-              </a:defRPr>
-            </a:pPr>
-          </a:p>
-          <a:p>
-            <a:pPr>
-              <a:spcBef>
-                <a:spcPts val="400"/>
+                  <a:srgbClr val="222222"/>
+                </a:solidFill>
+                <a:latin typeface="Microsoft YaHei"/>
+              </a:defRPr>
+            </a:pPr>
+          </a:p>
+          <a:p>
+            <a:pPr>
+              <a:spcBef>
+                <a:spcPts val="300"/>
               </a:spcBef>
               <a:defRPr sz="1200" b="1">
                 <a:solidFill>
-                  <a:srgbClr val="FF9F43"/>
-                </a:solidFill>
-              </a:defRPr>
-            </a:pPr>
-            <a:r>
-              <a:t>回滚 Checkpoint</a:t>
-            </a:r>
-          </a:p>
-          <a:p>
-            <a:pPr>
-              <a:spcBef>
-                <a:spcPts val="400"/>
-              </a:spcBef>
-              <a:defRPr sz="1100" b="1">
-                <a:solidFill>
-                  <a:srgbClr val="00E696"/>
-                </a:solidFill>
-              </a:defRPr>
-            </a:pPr>
-            <a:r>
-              <a:t>git read-tree &lt;sha&gt;</a:t>
-            </a:r>
-          </a:p>
-          <a:p>
-            <a:pPr>
-              <a:spcBef>
-                <a:spcPts val="400"/>
-              </a:spcBef>
-              <a:defRPr sz="1000" b="0">
-                <a:solidFill>
-                  <a:srgbClr val="CCCCDD"/>
-                </a:solidFill>
-              </a:defRPr>
-            </a:pPr>
-            <a:r>
-              <a:t>  → git checkout-index -a -f (恢复文件)</a:t>
-            </a:r>
-          </a:p>
-          <a:p>
-            <a:pPr>
-              <a:spcBef>
-                <a:spcPts val="400"/>
-              </a:spcBef>
-              <a:defRPr sz="1000" b="0">
-                <a:solidFill>
-                  <a:srgbClr val="CCCCDD"/>
-                </a:solidFill>
-              </a:defRPr>
-            </a:pPr>
-            <a:r>
-              <a:t>  → git clean -fd           (清理多余文件)</a:t>
-            </a:r>
-          </a:p>
-          <a:p>
-            <a:pPr>
-              <a:spcBef>
-                <a:spcPts val="400"/>
-              </a:spcBef>
-              <a:defRPr sz="1000" b="0">
-                <a:solidFill>
-                  <a:srgbClr val="CCCCDD"/>
-                </a:solidFill>
-              </a:defRPr>
-            </a:pPr>
-            <a:r>
-              <a:t>  → 截断 JSONL 到字节偏移    (恢复对话)</a:t>
-            </a:r>
-          </a:p>
-        </p:txBody>
-      </p:sp>
-      <p:sp>
-        <p:nvSpPr>
-          <p:cNvPr id="11" name="Rectangle 10"/>
+                  <a:srgbClr val="444444"/>
+                </a:solidFill>
+                <a:latin typeface="Microsoft YaHei"/>
+              </a:defRPr>
+            </a:pPr>
+            <a:r>
+              <a:t>上下文传递</a:t>
+            </a:r>
+          </a:p>
+          <a:p>
+            <a:pPr>
+              <a:spcBef>
+                <a:spcPts val="300"/>
+              </a:spcBef>
+              <a:defRPr sz="1200" b="0">
+                <a:solidFill>
+                  <a:srgbClr val="222222"/>
+                </a:solidFill>
+                <a:latin typeface="Microsoft YaHei"/>
+              </a:defRPr>
+            </a:pPr>
+            <a:r>
+              <a:t>WorkspaceResolver 在 Tool 上下文中缓存</a:t>
+            </a:r>
+          </a:p>
+          <a:p>
+            <a:pPr>
+              <a:spcBef>
+                <a:spcPts val="300"/>
+              </a:spcBef>
+              <a:defRPr sz="1200" b="0">
+                <a:solidFill>
+                  <a:srgbClr val="222222"/>
+                </a:solidFill>
+                <a:latin typeface="Microsoft YaHei"/>
+              </a:defRPr>
+            </a:pPr>
+            <a:r>
+              <a:t>workspaceDir，供 Hooks 回调使用</a:t>
+            </a:r>
+          </a:p>
+        </p:txBody>
+      </p:sp>
+      <p:sp>
+        <p:nvSpPr>
+          <p:cNvPr id="9" name="Rectangle 8"/>
           <p:cNvSpPr/>
           <p:nvPr/>
         </p:nvSpPr>
         <p:spPr>
           <a:xfrm>
-            <a:off x="8412480" y="1097280"/>
-            <a:ext cx="3474720" cy="2651760"/>
+            <a:off x="4160520" y="1051560"/>
+            <a:ext cx="3794760" cy="5303520"/>
           </a:xfrm>
           <a:prstGeom prst="rect">
             <a:avLst/>
           </a:prstGeom>
           <a:solidFill>
-            <a:srgbClr val="24243E"/>
+            <a:srgbClr val="F5F5F5"/>
           </a:solidFill>
           <a:ln>
             <a:noFill/>
@@ -3757,14 +3652,14 @@
       </p:sp>
       <p:sp>
         <p:nvSpPr>
-          <p:cNvPr id="12" name="TextBox 11"/>
+          <p:cNvPr id="10" name="TextBox 9"/>
           <p:cNvSpPr txBox="1"/>
           <p:nvPr/>
         </p:nvSpPr>
         <p:spPr>
           <a:xfrm>
-            <a:off x="8595360" y="1188720"/>
-            <a:ext cx="3108960" cy="365760"/>
+            <a:off x="4297680" y="1143000"/>
+            <a:ext cx="3474720" cy="365760"/>
           </a:xfrm>
           <a:prstGeom prst="rect">
             <a:avLst/>
@@ -3778,28 +3673,29 @@
           <a:lstStyle/>
           <a:p>
             <a:pPr algn="l">
-              <a:defRPr sz="1800" b="1">
-                <a:solidFill>
-                  <a:srgbClr val="00D2FF"/>
-                </a:solidFill>
-              </a:defRPr>
-            </a:pPr>
-            <a:r>
-              <a:t>关键设计决策</a:t>
-            </a:r>
-          </a:p>
-        </p:txBody>
-      </p:sp>
-      <p:sp>
-        <p:nvSpPr>
-          <p:cNvPr id="13" name="TextBox 12"/>
+              <a:defRPr sz="2400" b="1">
+                <a:solidFill>
+                  <a:srgbClr val="C81E1E"/>
+                </a:solidFill>
+                <a:latin typeface="Microsoft YaHei"/>
+              </a:defRPr>
+            </a:pPr>
+            <a:r>
+              <a:t>二、触发机制</a:t>
+            </a:r>
+          </a:p>
+        </p:txBody>
+      </p:sp>
+      <p:sp>
+        <p:nvSpPr>
+          <p:cNvPr id="11" name="TextBox 10"/>
           <p:cNvSpPr txBox="1"/>
           <p:nvPr/>
         </p:nvSpPr>
         <p:spPr>
           <a:xfrm>
-            <a:off x="8595360" y="1600200"/>
-            <a:ext cx="3108960" cy="2011680"/>
+            <a:off x="4297680" y="1554480"/>
+            <a:ext cx="3474720" cy="320040"/>
           </a:xfrm>
           <a:prstGeom prst="rect">
             <a:avLst/>
@@ -3813,211 +3709,330 @@
           <a:lstStyle/>
           <a:p>
             <a:pPr algn="l">
+              <a:defRPr sz="1200" b="1">
+                <a:solidFill>
+                  <a:srgbClr val="444444"/>
+                </a:solidFill>
+                <a:latin typeface="Microsoft YaHei"/>
+              </a:defRPr>
+            </a:pPr>
+            <a:r>
+              <a:t>触发模式（triggerOn 配置项）</a:t>
+            </a:r>
+          </a:p>
+          <a:p>
+            <a:pPr>
+              <a:spcBef>
+                <a:spcPts val="300"/>
+              </a:spcBef>
+              <a:defRPr sz="1200" b="1">
+                <a:solidFill>
+                  <a:srgbClr val="222222"/>
+                </a:solidFill>
+                <a:latin typeface="Microsoft YaHei"/>
+              </a:defRPr>
+            </a:pPr>
+            <a:r>
+              <a:t>mutating_tools（默认）</a:t>
+            </a:r>
+          </a:p>
+          <a:p>
+            <a:pPr>
+              <a:spcBef>
+                <a:spcPts val="300"/>
+              </a:spcBef>
               <a:defRPr sz="1200" b="0">
                 <a:solidFill>
-                  <a:srgbClr val="FFFFFF"/>
-                </a:solidFill>
-              </a:defRPr>
-            </a:pPr>
-          </a:p>
-          <a:p>
-            <a:pPr>
-              <a:spcBef>
-                <a:spcPts val="400"/>
-              </a:spcBef>
-              <a:defRPr sz="1100" b="1">
-                <a:solidFill>
-                  <a:srgbClr val="00E696"/>
-                </a:solidFill>
-              </a:defRPr>
-            </a:pPr>
-            <a:r>
-              <a:t>▸ 零侵入</a:t>
-            </a:r>
-          </a:p>
-          <a:p>
-            <a:pPr>
-              <a:spcBef>
-                <a:spcPts val="100"/>
-              </a:spcBef>
-              <a:defRPr sz="1000" b="0">
-                <a:solidFill>
-                  <a:srgbClr val="CCCCDD"/>
-                </a:solidFill>
-              </a:defRPr>
-            </a:pPr>
-            <a:r>
-              <a:t>  不影响分支/HEAD/工作流</a:t>
-            </a:r>
-          </a:p>
-          <a:p>
-            <a:pPr>
-              <a:spcBef>
-                <a:spcPts val="400"/>
-              </a:spcBef>
-              <a:defRPr sz="1100" b="1">
-                <a:solidFill>
-                  <a:srgbClr val="00E696"/>
-                </a:solidFill>
-              </a:defRPr>
-            </a:pPr>
-            <a:r>
-              <a:t>▸ 可配置触发</a:t>
-            </a:r>
-          </a:p>
-          <a:p>
-            <a:pPr>
-              <a:spcBef>
-                <a:spcPts val="100"/>
-              </a:spcBef>
-              <a:defRPr sz="1000" b="0">
-                <a:solidFill>
-                  <a:srgbClr val="CCCCDD"/>
-                </a:solidFill>
-              </a:defRPr>
-            </a:pPr>
-            <a:r>
-              <a:t>  mutating_tools | all | manual</a:t>
-            </a:r>
-          </a:p>
-          <a:p>
-            <a:pPr>
-              <a:spcBef>
-                <a:spcPts val="400"/>
-              </a:spcBef>
-              <a:defRPr sz="1100" b="1">
-                <a:solidFill>
-                  <a:srgbClr val="00E696"/>
-                </a:solidFill>
-              </a:defRPr>
-            </a:pPr>
-            <a:r>
-              <a:t>▸ 优雅降级</a:t>
-            </a:r>
-          </a:p>
-          <a:p>
-            <a:pPr>
-              <a:spcBef>
-                <a:spcPts val="100"/>
-              </a:spcBef>
-              <a:defRPr sz="1000" b="0">
-                <a:solidFill>
-                  <a:srgbClr val="CCCCDD"/>
-                </a:solidFill>
-              </a:defRPr>
-            </a:pPr>
-            <a:r>
-              <a:t>  checkpoint 失败不中断 agent</a:t>
-            </a:r>
-          </a:p>
-          <a:p>
-            <a:pPr>
-              <a:spcBef>
-                <a:spcPts val="400"/>
-              </a:spcBef>
-              <a:defRPr sz="1100" b="1">
-                <a:solidFill>
-                  <a:srgbClr val="00E696"/>
-                </a:solidFill>
-              </a:defRPr>
-            </a:pPr>
-            <a:r>
-              <a:t>▸ 双重清理</a:t>
-            </a:r>
-          </a:p>
-          <a:p>
-            <a:pPr>
-              <a:spcBef>
-                <a:spcPts val="100"/>
-              </a:spcBef>
-              <a:defRPr sz="1000" b="0">
-                <a:solidFill>
-                  <a:srgbClr val="CCCCDD"/>
-                </a:solidFill>
-              </a:defRPr>
-            </a:pPr>
-            <a:r>
-              <a:t>  每 session 200 上限 + 30 天保留</a:t>
-            </a:r>
-          </a:p>
-          <a:p>
-            <a:pPr>
-              <a:spcBef>
-                <a:spcPts val="400"/>
-              </a:spcBef>
-              <a:defRPr sz="1100" b="1">
-                <a:solidFill>
-                  <a:srgbClr val="00E696"/>
-                </a:solidFill>
-              </a:defRPr>
-            </a:pPr>
-            <a:r>
-              <a:t>▸ 并发安全</a:t>
-            </a:r>
-          </a:p>
-          <a:p>
-            <a:pPr>
-              <a:spcBef>
-                <a:spcPts val="100"/>
-              </a:spcBef>
-              <a:defRPr sz="1000" b="0">
-                <a:solidFill>
-                  <a:srgbClr val="CCCCDD"/>
-                </a:solidFill>
-              </a:defRPr>
-            </a:pPr>
-            <a:r>
-              <a:t>  detached commit 无锁冲突</a:t>
-            </a:r>
-          </a:p>
-          <a:p>
-            <a:pPr>
-              <a:spcBef>
-                <a:spcPts val="400"/>
-              </a:spcBef>
-              <a:defRPr sz="1100" b="1">
-                <a:solidFill>
-                  <a:srgbClr val="00E696"/>
-                </a:solidFill>
-              </a:defRPr>
-            </a:pPr>
-            <a:r>
-              <a:t>▸ 轻量存储</a:t>
-            </a:r>
-          </a:p>
-          <a:p>
-            <a:pPr>
-              <a:spcBef>
-                <a:spcPts val="100"/>
-              </a:spcBef>
-              <a:defRPr sz="1000" b="0">
-                <a:solidFill>
-                  <a:srgbClr val="CCCCDD"/>
-                </a:solidFill>
-              </a:defRPr>
-            </a:pPr>
-            <a:r>
-              <a:t>  仅 git 对象，几 KB/快照</a:t>
-            </a:r>
-          </a:p>
-        </p:txBody>
-      </p:sp>
-      <p:sp>
-        <p:nvSpPr>
-          <p:cNvPr id="14" name="Rectangle 13"/>
+                  <a:srgbClr val="222222"/>
+                </a:solidFill>
+                <a:latin typeface="Microsoft YaHei"/>
+              </a:defRPr>
+            </a:pPr>
+            <a:r>
+              <a:t>  仅在可能修改文件的工具调用后触发</a:t>
+            </a:r>
+          </a:p>
+          <a:p>
+            <a:pPr>
+              <a:spcBef>
+                <a:spcPts val="300"/>
+              </a:spcBef>
+              <a:defRPr sz="1200" b="1">
+                <a:solidFill>
+                  <a:srgbClr val="222222"/>
+                </a:solidFill>
+                <a:latin typeface="Microsoft YaHei"/>
+              </a:defRPr>
+            </a:pPr>
+            <a:r>
+              <a:t>all_tools</a:t>
+            </a:r>
+          </a:p>
+          <a:p>
+            <a:pPr>
+              <a:spcBef>
+                <a:spcPts val="300"/>
+              </a:spcBef>
+              <a:defRPr sz="1200" b="0">
+                <a:solidFill>
+                  <a:srgbClr val="222222"/>
+                </a:solidFill>
+                <a:latin typeface="Microsoft YaHei"/>
+              </a:defRPr>
+            </a:pPr>
+            <a:r>
+              <a:t>  每次工具调用后都触发</a:t>
+            </a:r>
+          </a:p>
+          <a:p>
+            <a:pPr>
+              <a:spcBef>
+                <a:spcPts val="300"/>
+              </a:spcBef>
+              <a:defRPr sz="1200" b="1">
+                <a:solidFill>
+                  <a:srgbClr val="222222"/>
+                </a:solidFill>
+                <a:latin typeface="Microsoft YaHei"/>
+              </a:defRPr>
+            </a:pPr>
+            <a:r>
+              <a:t>manual</a:t>
+            </a:r>
+          </a:p>
+          <a:p>
+            <a:pPr>
+              <a:spcBef>
+                <a:spcPts val="300"/>
+              </a:spcBef>
+              <a:defRPr sz="1200" b="0">
+                <a:solidFill>
+                  <a:srgbClr val="222222"/>
+                </a:solidFill>
+                <a:latin typeface="Microsoft YaHei"/>
+              </a:defRPr>
+            </a:pPr>
+            <a:r>
+              <a:t>  仅通过 Agent Tool 手动创建</a:t>
+            </a:r>
+          </a:p>
+          <a:p>
+            <a:pPr>
+              <a:spcBef>
+                <a:spcPts val="300"/>
+              </a:spcBef>
+              <a:defRPr sz="600" b="0">
+                <a:solidFill>
+                  <a:srgbClr val="222222"/>
+                </a:solidFill>
+                <a:latin typeface="Microsoft YaHei"/>
+              </a:defRPr>
+            </a:pPr>
+          </a:p>
+          <a:p>
+            <a:pPr>
+              <a:spcBef>
+                <a:spcPts val="300"/>
+              </a:spcBef>
+              <a:defRPr sz="1200" b="1">
+                <a:solidFill>
+                  <a:srgbClr val="444444"/>
+                </a:solidFill>
+                <a:latin typeface="Microsoft YaHei"/>
+              </a:defRPr>
+            </a:pPr>
+            <a:r>
+              <a:t>过滤逻辑</a:t>
+            </a:r>
+          </a:p>
+          <a:p>
+            <a:pPr>
+              <a:spcBef>
+                <a:spcPts val="300"/>
+              </a:spcBef>
+              <a:defRPr sz="1200" b="0">
+                <a:solidFill>
+                  <a:srgbClr val="222222"/>
+                </a:solidFill>
+                <a:latin typeface="Microsoft YaHei"/>
+              </a:defRPr>
+            </a:pPr>
+            <a:r>
+              <a:t>默认排除只读工具（不创建 checkpoint）：</a:t>
+            </a:r>
+          </a:p>
+          <a:p>
+            <a:pPr>
+              <a:spcBef>
+                <a:spcPts val="300"/>
+              </a:spcBef>
+              <a:defRPr sz="1200" b="0">
+                <a:solidFill>
+                  <a:srgbClr val="444444"/>
+                </a:solidFill>
+                <a:latin typeface="Microsoft YaHei"/>
+              </a:defRPr>
+            </a:pPr>
+            <a:r>
+              <a:t>  read, glob, grep, memory_search, memory_get</a:t>
+            </a:r>
+          </a:p>
+          <a:p>
+            <a:pPr>
+              <a:spcBef>
+                <a:spcPts val="300"/>
+              </a:spcBef>
+              <a:defRPr sz="1200" b="0">
+                <a:solidFill>
+                  <a:srgbClr val="222222"/>
+                </a:solidFill>
+                <a:latin typeface="Microsoft YaHei"/>
+              </a:defRPr>
+            </a:pPr>
+            <a:r>
+              <a:t>工具名大小写不敏感匹配</a:t>
+            </a:r>
+          </a:p>
+          <a:p>
+            <a:pPr>
+              <a:spcBef>
+                <a:spcPts val="300"/>
+              </a:spcBef>
+              <a:defRPr sz="600" b="0">
+                <a:solidFill>
+                  <a:srgbClr val="222222"/>
+                </a:solidFill>
+                <a:latin typeface="Microsoft YaHei"/>
+              </a:defRPr>
+            </a:pPr>
+          </a:p>
+          <a:p>
+            <a:pPr>
+              <a:spcBef>
+                <a:spcPts val="300"/>
+              </a:spcBef>
+              <a:defRPr sz="1200" b="1">
+                <a:solidFill>
+                  <a:srgbClr val="444444"/>
+                </a:solidFill>
+                <a:latin typeface="Microsoft YaHei"/>
+              </a:defRPr>
+            </a:pPr>
+            <a:r>
+              <a:t>容错设计</a:t>
+            </a:r>
+          </a:p>
+          <a:p>
+            <a:pPr>
+              <a:spcBef>
+                <a:spcPts val="300"/>
+              </a:spcBef>
+              <a:defRPr sz="1200" b="0">
+                <a:solidFill>
+                  <a:srgbClr val="222222"/>
+                </a:solidFill>
+                <a:latin typeface="Microsoft YaHei"/>
+              </a:defRPr>
+            </a:pPr>
+            <a:r>
+              <a:t>checkpoint 创建失败仅记录日志</a:t>
+            </a:r>
+          </a:p>
+          <a:p>
+            <a:pPr>
+              <a:spcBef>
+                <a:spcPts val="300"/>
+              </a:spcBef>
+              <a:defRPr sz="1200" b="0">
+                <a:solidFill>
+                  <a:srgbClr val="222222"/>
+                </a:solidFill>
+                <a:latin typeface="Microsoft YaHei"/>
+              </a:defRPr>
+            </a:pPr>
+            <a:r>
+              <a:t>不会中断 Agent 执行流程</a:t>
+            </a:r>
+          </a:p>
+          <a:p>
+            <a:pPr>
+              <a:spcBef>
+                <a:spcPts val="300"/>
+              </a:spcBef>
+              <a:defRPr sz="600" b="0">
+                <a:solidFill>
+                  <a:srgbClr val="222222"/>
+                </a:solidFill>
+                <a:latin typeface="Microsoft YaHei"/>
+              </a:defRPr>
+            </a:pPr>
+          </a:p>
+          <a:p>
+            <a:pPr>
+              <a:spcBef>
+                <a:spcPts val="300"/>
+              </a:spcBef>
+              <a:defRPr sz="1200" b="1">
+                <a:solidFill>
+                  <a:srgbClr val="444444"/>
+                </a:solidFill>
+                <a:latin typeface="Microsoft YaHei"/>
+              </a:defRPr>
+            </a:pPr>
+            <a:r>
+              <a:t>触发数据流</a:t>
+            </a:r>
+          </a:p>
+          <a:p>
+            <a:pPr>
+              <a:spcBef>
+                <a:spcPts val="300"/>
+              </a:spcBef>
+              <a:defRPr sz="1200" b="0">
+                <a:solidFill>
+                  <a:srgbClr val="222222"/>
+                </a:solidFill>
+                <a:latin typeface="Microsoft YaHei"/>
+              </a:defRPr>
+            </a:pPr>
+            <a:r>
+              <a:t>Hook 事件 → shouldCreateCheckpoint() 判断</a:t>
+            </a:r>
+          </a:p>
+          <a:p>
+            <a:pPr>
+              <a:spcBef>
+                <a:spcPts val="300"/>
+              </a:spcBef>
+              <a:defRPr sz="1200" b="0">
+                <a:solidFill>
+                  <a:srgbClr val="222222"/>
+                </a:solidFill>
+                <a:latin typeface="Microsoft YaHei"/>
+              </a:defRPr>
+            </a:pPr>
+            <a:r>
+              <a:t>→ engine.createCheckpoint() → Git 快照 + 持久化</a:t>
+            </a:r>
+          </a:p>
+        </p:txBody>
+      </p:sp>
+      <p:sp>
+        <p:nvSpPr>
+          <p:cNvPr id="12" name="Rectangle 11"/>
           <p:cNvSpPr/>
           <p:nvPr/>
         </p:nvSpPr>
         <p:spPr>
           <a:xfrm>
-            <a:off x="365760" y="3977639"/>
-            <a:ext cx="11521440" cy="2606040"/>
+            <a:off x="8138160" y="1051560"/>
+            <a:ext cx="3703320" cy="5303520"/>
           </a:xfrm>
           <a:prstGeom prst="rect">
             <a:avLst/>
           </a:prstGeom>
           <a:solidFill>
-            <a:srgbClr val="24243E"/>
+            <a:srgbClr val="F5F5F5"/>
           </a:solidFill>
           <a:ln>
             <a:noFill/>
@@ -4048,14 +4063,14 @@
       </p:sp>
       <p:sp>
         <p:nvSpPr>
-          <p:cNvPr id="15" name="TextBox 14"/>
+          <p:cNvPr id="13" name="TextBox 12"/>
           <p:cNvSpPr txBox="1"/>
           <p:nvPr/>
         </p:nvSpPr>
         <p:spPr>
           <a:xfrm>
-            <a:off x="548640" y="4023360"/>
-            <a:ext cx="2743200" cy="365760"/>
+            <a:off x="8275320" y="1143000"/>
+            <a:ext cx="3383280" cy="365760"/>
           </a:xfrm>
           <a:prstGeom prst="rect">
             <a:avLst/>
@@ -4069,72 +4084,29 @@
           <a:lstStyle/>
           <a:p>
             <a:pPr algn="l">
-              <a:defRPr sz="1800" b="1">
-                <a:solidFill>
-                  <a:srgbClr val="00D2FF"/>
-                </a:solidFill>
-              </a:defRPr>
-            </a:pPr>
-            <a:r>
-              <a:t>模块架构</a:t>
-            </a:r>
-          </a:p>
-        </p:txBody>
-      </p:sp>
-      <p:sp>
-        <p:nvSpPr>
-          <p:cNvPr id="16" name="Rectangle 15"/>
-          <p:cNvSpPr/>
+              <a:defRPr sz="2400" b="1">
+                <a:solidFill>
+                  <a:srgbClr val="C81E1E"/>
+                </a:solidFill>
+                <a:latin typeface="Microsoft YaHei"/>
+              </a:defRPr>
+            </a:pPr>
+            <a:r>
+              <a:t>三、保存机制</a:t>
+            </a:r>
+          </a:p>
+        </p:txBody>
+      </p:sp>
+      <p:sp>
+        <p:nvSpPr>
+          <p:cNvPr id="14" name="TextBox 13"/>
+          <p:cNvSpPr txBox="1"/>
           <p:nvPr/>
         </p:nvSpPr>
         <p:spPr>
           <a:xfrm>
-            <a:off x="502920" y="4526280"/>
-            <a:ext cx="1463040" cy="1554480"/>
-          </a:xfrm>
-          <a:prstGeom prst="rect">
-            <a:avLst/>
-          </a:prstGeom>
-          <a:solidFill>
-            <a:srgbClr val="2E2E4E"/>
-          </a:solidFill>
-          <a:ln>
-            <a:noFill/>
-          </a:ln>
-          <a:effectLst/>
-        </p:spPr>
-        <p:style>
-          <a:lnRef idx="1">
-            <a:schemeClr val="accent1"/>
-          </a:lnRef>
-          <a:fillRef idx="3">
-            <a:schemeClr val="accent1"/>
-          </a:fillRef>
-          <a:effectRef idx="2">
-            <a:schemeClr val="accent1"/>
-          </a:effectRef>
-          <a:fontRef idx="minor">
-            <a:schemeClr val="lt1"/>
-          </a:fontRef>
-        </p:style>
-        <p:txBody>
-          <a:bodyPr rtlCol="0" anchor="ctr"/>
-          <a:lstStyle/>
-          <a:p>
-            <a:pPr algn="ctr"/>
-          </a:p>
-        </p:txBody>
-      </p:sp>
-      <p:sp>
-        <p:nvSpPr>
-          <p:cNvPr id="17" name="TextBox 16"/>
-          <p:cNvSpPr txBox="1"/>
-          <p:nvPr/>
-        </p:nvSpPr>
-        <p:spPr>
-          <a:xfrm>
-            <a:off x="594360" y="4617720"/>
-            <a:ext cx="1280160" cy="320040"/>
+            <a:off x="8275320" y="1554480"/>
+            <a:ext cx="3383280" cy="320040"/>
           </a:xfrm>
           <a:prstGeom prst="rect">
             <a:avLst/>
@@ -4147,1272 +4119,372 @@
           </a:bodyPr>
           <a:lstStyle/>
           <a:p>
-            <a:pPr algn="ctr">
-              <a:defRPr sz="1300" b="1">
-                <a:solidFill>
-                  <a:srgbClr val="00D2FF"/>
-                </a:solidFill>
-              </a:defRPr>
-            </a:pPr>
-            <a:r>
-              <a:t>Engine</a:t>
-            </a:r>
-          </a:p>
-        </p:txBody>
-      </p:sp>
-      <p:sp>
-        <p:nvSpPr>
-          <p:cNvPr id="18" name="TextBox 17"/>
-          <p:cNvSpPr txBox="1"/>
-          <p:nvPr/>
-        </p:nvSpPr>
-        <p:spPr>
-          <a:xfrm>
-            <a:off x="594360" y="4937760"/>
-            <a:ext cx="1280160" cy="320040"/>
-          </a:xfrm>
-          <a:prstGeom prst="rect">
-            <a:avLst/>
-          </a:prstGeom>
-          <a:noFill/>
-        </p:spPr>
-        <p:txBody>
-          <a:bodyPr wrap="square">
-            <a:spAutoFit/>
-          </a:bodyPr>
-          <a:lstStyle/>
-          <a:p>
-            <a:pPr algn="ctr">
-              <a:defRPr sz="900" b="0">
-                <a:solidFill>
-                  <a:srgbClr val="FF9F43"/>
-                </a:solidFill>
-              </a:defRPr>
-            </a:pPr>
-            <a:r>
-              <a:t>checkpoint-engine.ts</a:t>
-            </a:r>
-          </a:p>
-        </p:txBody>
-      </p:sp>
-      <p:sp>
-        <p:nvSpPr>
-          <p:cNvPr id="19" name="TextBox 18"/>
-          <p:cNvSpPr txBox="1"/>
-          <p:nvPr/>
-        </p:nvSpPr>
-        <p:spPr>
-          <a:xfrm>
-            <a:off x="594360" y="5303520"/>
-            <a:ext cx="1280160" cy="640080"/>
-          </a:xfrm>
-          <a:prstGeom prst="rect">
-            <a:avLst/>
-          </a:prstGeom>
-          <a:noFill/>
-        </p:spPr>
-        <p:txBody>
-          <a:bodyPr wrap="square">
-            <a:spAutoFit/>
-          </a:bodyPr>
-          <a:lstStyle/>
-          <a:p>
-            <a:pPr algn="ctr">
+            <a:pPr algn="l">
+              <a:defRPr sz="1200" b="1">
+                <a:solidFill>
+                  <a:srgbClr val="444444"/>
+                </a:solidFill>
+                <a:latin typeface="Microsoft YaHei"/>
+              </a:defRPr>
+            </a:pPr>
+            <a:r>
+              <a:t>Git 层（文件快照）</a:t>
+            </a:r>
+          </a:p>
+          <a:p>
+            <a:pPr>
+              <a:spcBef>
+                <a:spcPts val="300"/>
+              </a:spcBef>
+              <a:defRPr sz="1200" b="0">
+                <a:solidFill>
+                  <a:srgbClr val="222222"/>
+                </a:solidFill>
+                <a:latin typeface="Microsoft YaHei"/>
+              </a:defRPr>
+            </a:pPr>
+            <a:r>
+              <a:t>git add -A             暂存所有变更</a:t>
+            </a:r>
+          </a:p>
+          <a:p>
+            <a:pPr>
+              <a:spcBef>
+                <a:spcPts val="300"/>
+              </a:spcBef>
+              <a:defRPr sz="1200" b="0">
+                <a:solidFill>
+                  <a:srgbClr val="222222"/>
+                </a:solidFill>
+                <a:latin typeface="Microsoft YaHei"/>
+              </a:defRPr>
+            </a:pPr>
+            <a:r>
+              <a:t>git write-tree         生成 tree 对象</a:t>
+            </a:r>
+          </a:p>
+          <a:p>
+            <a:pPr>
+              <a:spcBef>
+                <a:spcPts val="300"/>
+              </a:spcBef>
+              <a:defRPr sz="1200" b="0">
+                <a:solidFill>
+                  <a:srgbClr val="222222"/>
+                </a:solidFill>
+                <a:latin typeface="Microsoft YaHei"/>
+              </a:defRPr>
+            </a:pPr>
+            <a:r>
+              <a:t>git commit-tree -p ... 创建游离 commit</a:t>
+            </a:r>
+          </a:p>
+          <a:p>
+            <a:pPr>
+              <a:spcBef>
+                <a:spcPts val="300"/>
+              </a:spcBef>
+              <a:defRPr sz="1200" b="0">
+                <a:solidFill>
+                  <a:srgbClr val="222222"/>
+                </a:solidFill>
+                <a:latin typeface="Microsoft YaHei"/>
+              </a:defRPr>
+            </a:pPr>
+            <a:r>
+              <a:t>git reset              恢复索引状态</a:t>
+            </a:r>
+          </a:p>
+          <a:p>
+            <a:pPr>
+              <a:spcBef>
+                <a:spcPts val="300"/>
+              </a:spcBef>
+              <a:defRPr sz="1200" b="0">
+                <a:solidFill>
+                  <a:srgbClr val="444444"/>
+                </a:solidFill>
+                <a:latin typeface="Microsoft YaHei"/>
+              </a:defRPr>
+            </a:pPr>
+            <a:r>
+              <a:t>不影响 HEAD / 分支 / 工作流</a:t>
+            </a:r>
+          </a:p>
+          <a:p>
+            <a:pPr>
+              <a:spcBef>
+                <a:spcPts val="300"/>
+              </a:spcBef>
+              <a:defRPr sz="600" b="0">
+                <a:solidFill>
+                  <a:srgbClr val="222222"/>
+                </a:solidFill>
+                <a:latin typeface="Microsoft YaHei"/>
+              </a:defRPr>
+            </a:pPr>
+          </a:p>
+          <a:p>
+            <a:pPr>
+              <a:spcBef>
+                <a:spcPts val="300"/>
+              </a:spcBef>
+              <a:defRPr sz="1200" b="1">
+                <a:solidFill>
+                  <a:srgbClr val="444444"/>
+                </a:solidFill>
+                <a:latin typeface="Microsoft YaHei"/>
+              </a:defRPr>
+            </a:pPr>
+            <a:r>
+              <a:t>元数据层（文件系统）</a:t>
+            </a:r>
+          </a:p>
+          <a:p>
+            <a:pPr>
+              <a:spcBef>
+                <a:spcPts val="300"/>
+              </a:spcBef>
+              <a:defRPr sz="1200" b="0">
+                <a:solidFill>
+                  <a:srgbClr val="222222"/>
+                </a:solidFill>
+                <a:latin typeface="Microsoft YaHei"/>
+              </a:defRPr>
+            </a:pPr>
+            <a:r>
+              <a:t>存储路径：~/.openclaw/checkpoints/</a:t>
+            </a:r>
+          </a:p>
+          <a:p>
+            <a:pPr>
+              <a:spcBef>
+                <a:spcPts val="300"/>
+              </a:spcBef>
+              <a:defRPr sz="400" b="0">
+                <a:solidFill>
+                  <a:srgbClr val="222222"/>
+                </a:solidFill>
+                <a:latin typeface="Microsoft YaHei"/>
+              </a:defRPr>
+            </a:pPr>
+          </a:p>
+          <a:p>
+            <a:pPr>
+              <a:spcBef>
+                <a:spcPts val="300"/>
+              </a:spcBef>
               <a:defRPr sz="1100" b="0">
                 <a:solidFill>
-                  <a:srgbClr val="CCCCDD"/>
-                </a:solidFill>
-              </a:defRPr>
-            </a:pPr>
-            <a:r>
-              <a:t>创建/恢复/裁剪</a:t>
-            </a:r>
-          </a:p>
-        </p:txBody>
-      </p:sp>
-      <p:sp>
-        <p:nvSpPr>
-          <p:cNvPr id="20" name="Rectangle 19"/>
-          <p:cNvSpPr/>
-          <p:nvPr/>
-        </p:nvSpPr>
-        <p:spPr>
-          <a:xfrm>
-            <a:off x="2103120" y="4526280"/>
-            <a:ext cx="1463040" cy="1554480"/>
-          </a:xfrm>
-          <a:prstGeom prst="rect">
-            <a:avLst/>
-          </a:prstGeom>
-          <a:solidFill>
-            <a:srgbClr val="2E2E4E"/>
-          </a:solidFill>
-          <a:ln>
-            <a:noFill/>
-          </a:ln>
-          <a:effectLst/>
-        </p:spPr>
-        <p:style>
-          <a:lnRef idx="1">
-            <a:schemeClr val="accent1"/>
-          </a:lnRef>
-          <a:fillRef idx="3">
-            <a:schemeClr val="accent1"/>
-          </a:fillRef>
-          <a:effectRef idx="2">
-            <a:schemeClr val="accent1"/>
-          </a:effectRef>
-          <a:fontRef idx="minor">
-            <a:schemeClr val="lt1"/>
-          </a:fontRef>
-        </p:style>
-        <p:txBody>
-          <a:bodyPr rtlCol="0" anchor="ctr"/>
-          <a:lstStyle/>
-          <a:p>
-            <a:pPr algn="ctr"/>
-          </a:p>
-        </p:txBody>
-      </p:sp>
-      <p:sp>
-        <p:nvSpPr>
-          <p:cNvPr id="21" name="TextBox 20"/>
-          <p:cNvSpPr txBox="1"/>
-          <p:nvPr/>
-        </p:nvSpPr>
-        <p:spPr>
-          <a:xfrm>
-            <a:off x="2194560" y="4617720"/>
-            <a:ext cx="1280160" cy="320040"/>
-          </a:xfrm>
-          <a:prstGeom prst="rect">
-            <a:avLst/>
-          </a:prstGeom>
-          <a:noFill/>
-        </p:spPr>
-        <p:txBody>
-          <a:bodyPr wrap="square">
-            <a:spAutoFit/>
-          </a:bodyPr>
-          <a:lstStyle/>
-          <a:p>
-            <a:pPr algn="ctr">
-              <a:defRPr sz="1300" b="1">
-                <a:solidFill>
-                  <a:srgbClr val="00D2FF"/>
-                </a:solidFill>
-              </a:defRPr>
-            </a:pPr>
-            <a:r>
-              <a:t>Git Backend</a:t>
-            </a:r>
-          </a:p>
-        </p:txBody>
-      </p:sp>
-      <p:sp>
-        <p:nvSpPr>
-          <p:cNvPr id="22" name="TextBox 21"/>
-          <p:cNvSpPr txBox="1"/>
-          <p:nvPr/>
-        </p:nvSpPr>
-        <p:spPr>
-          <a:xfrm>
-            <a:off x="2194560" y="4937760"/>
-            <a:ext cx="1280160" cy="320040"/>
-          </a:xfrm>
-          <a:prstGeom prst="rect">
-            <a:avLst/>
-          </a:prstGeom>
-          <a:noFill/>
-        </p:spPr>
-        <p:txBody>
-          <a:bodyPr wrap="square">
-            <a:spAutoFit/>
-          </a:bodyPr>
-          <a:lstStyle/>
-          <a:p>
-            <a:pPr algn="ctr">
-              <a:defRPr sz="900" b="0">
-                <a:solidFill>
-                  <a:srgbClr val="FF9F43"/>
-                </a:solidFill>
-              </a:defRPr>
-            </a:pPr>
-            <a:r>
-              <a:t>git-backend.ts</a:t>
-            </a:r>
-          </a:p>
-        </p:txBody>
-      </p:sp>
-      <p:sp>
-        <p:nvSpPr>
-          <p:cNvPr id="23" name="TextBox 22"/>
-          <p:cNvSpPr txBox="1"/>
-          <p:nvPr/>
-        </p:nvSpPr>
-        <p:spPr>
-          <a:xfrm>
-            <a:off x="2194560" y="5303520"/>
-            <a:ext cx="1280160" cy="640080"/>
-          </a:xfrm>
-          <a:prstGeom prst="rect">
-            <a:avLst/>
-          </a:prstGeom>
-          <a:noFill/>
-        </p:spPr>
-        <p:txBody>
-          <a:bodyPr wrap="square">
-            <a:spAutoFit/>
-          </a:bodyPr>
-          <a:lstStyle/>
-          <a:p>
-            <a:pPr algn="ctr">
+                  <a:srgbClr val="444444"/>
+                </a:solidFill>
+                <a:latin typeface="Microsoft YaHei"/>
+              </a:defRPr>
+            </a:pPr>
+            <a:r>
+              <a:t>&lt;storagePath&gt;/</a:t>
+            </a:r>
+          </a:p>
+          <a:p>
+            <a:pPr>
+              <a:spcBef>
+                <a:spcPts val="300"/>
+              </a:spcBef>
               <a:defRPr sz="1100" b="0">
                 <a:solidFill>
-                  <a:srgbClr val="CCCCDD"/>
-                </a:solidFill>
-              </a:defRPr>
-            </a:pPr>
-            <a:r>
-              <a:t>commit-tree 操作</a:t>
-            </a:r>
-          </a:p>
-        </p:txBody>
-      </p:sp>
-      <p:sp>
-        <p:nvSpPr>
-          <p:cNvPr id="24" name="Rectangle 23"/>
-          <p:cNvSpPr/>
-          <p:nvPr/>
-        </p:nvSpPr>
-        <p:spPr>
-          <a:xfrm>
-            <a:off x="3703320" y="4526280"/>
-            <a:ext cx="1463040" cy="1554480"/>
-          </a:xfrm>
-          <a:prstGeom prst="rect">
-            <a:avLst/>
-          </a:prstGeom>
-          <a:solidFill>
-            <a:srgbClr val="2E2E4E"/>
-          </a:solidFill>
-          <a:ln>
-            <a:noFill/>
-          </a:ln>
-          <a:effectLst/>
-        </p:spPr>
-        <p:style>
-          <a:lnRef idx="1">
-            <a:schemeClr val="accent1"/>
-          </a:lnRef>
-          <a:fillRef idx="3">
-            <a:schemeClr val="accent1"/>
-          </a:fillRef>
-          <a:effectRef idx="2">
-            <a:schemeClr val="accent1"/>
-          </a:effectRef>
-          <a:fontRef idx="minor">
-            <a:schemeClr val="lt1"/>
-          </a:fontRef>
-        </p:style>
-        <p:txBody>
-          <a:bodyPr rtlCol="0" anchor="ctr"/>
-          <a:lstStyle/>
-          <a:p>
-            <a:pPr algn="ctr"/>
-          </a:p>
-        </p:txBody>
-      </p:sp>
-      <p:sp>
-        <p:nvSpPr>
-          <p:cNvPr id="25" name="TextBox 24"/>
-          <p:cNvSpPr txBox="1"/>
-          <p:nvPr/>
-        </p:nvSpPr>
-        <p:spPr>
-          <a:xfrm>
-            <a:off x="3794760" y="4617720"/>
-            <a:ext cx="1280160" cy="320040"/>
-          </a:xfrm>
-          <a:prstGeom prst="rect">
-            <a:avLst/>
-          </a:prstGeom>
-          <a:noFill/>
-        </p:spPr>
-        <p:txBody>
-          <a:bodyPr wrap="square">
-            <a:spAutoFit/>
-          </a:bodyPr>
-          <a:lstStyle/>
-          <a:p>
-            <a:pPr algn="ctr">
-              <a:defRPr sz="1300" b="1">
-                <a:solidFill>
-                  <a:srgbClr val="00D2FF"/>
-                </a:solidFill>
-              </a:defRPr>
-            </a:pPr>
-            <a:r>
-              <a:t>Store</a:t>
-            </a:r>
-          </a:p>
-        </p:txBody>
-      </p:sp>
-      <p:sp>
-        <p:nvSpPr>
-          <p:cNvPr id="26" name="TextBox 25"/>
-          <p:cNvSpPr txBox="1"/>
-          <p:nvPr/>
-        </p:nvSpPr>
-        <p:spPr>
-          <a:xfrm>
-            <a:off x="3794760" y="4937760"/>
-            <a:ext cx="1280160" cy="320040"/>
-          </a:xfrm>
-          <a:prstGeom prst="rect">
-            <a:avLst/>
-          </a:prstGeom>
-          <a:noFill/>
-        </p:spPr>
-        <p:txBody>
-          <a:bodyPr wrap="square">
-            <a:spAutoFit/>
-          </a:bodyPr>
-          <a:lstStyle/>
-          <a:p>
-            <a:pPr algn="ctr">
-              <a:defRPr sz="900" b="0">
-                <a:solidFill>
-                  <a:srgbClr val="FF9F43"/>
-                </a:solidFill>
-              </a:defRPr>
-            </a:pPr>
-            <a:r>
-              <a:t>store.ts</a:t>
-            </a:r>
-          </a:p>
-        </p:txBody>
-      </p:sp>
-      <p:sp>
-        <p:nvSpPr>
-          <p:cNvPr id="27" name="TextBox 26"/>
-          <p:cNvSpPr txBox="1"/>
-          <p:nvPr/>
-        </p:nvSpPr>
-        <p:spPr>
-          <a:xfrm>
-            <a:off x="3794760" y="5303520"/>
-            <a:ext cx="1280160" cy="640080"/>
-          </a:xfrm>
-          <a:prstGeom prst="rect">
-            <a:avLst/>
-          </a:prstGeom>
-          <a:noFill/>
-        </p:spPr>
-        <p:txBody>
-          <a:bodyPr wrap="square">
-            <a:spAutoFit/>
-          </a:bodyPr>
-          <a:lstStyle/>
-          <a:p>
-            <a:pPr algn="ctr">
+                  <a:srgbClr val="444444"/>
+                </a:solidFill>
+                <a:latin typeface="Microsoft YaHei"/>
+              </a:defRPr>
+            </a:pPr>
+            <a:r>
+              <a:t>  &lt;agentId&gt;/</a:t>
+            </a:r>
+          </a:p>
+          <a:p>
+            <a:pPr>
+              <a:spcBef>
+                <a:spcPts val="300"/>
+              </a:spcBef>
               <a:defRPr sz="1100" b="0">
                 <a:solidFill>
-                  <a:srgbClr val="CCCCDD"/>
-                </a:solidFill>
-              </a:defRPr>
-            </a:pPr>
-            <a:r>
-              <a:t>元数据持久化</a:t>
-            </a:r>
-          </a:p>
-        </p:txBody>
-      </p:sp>
-      <p:sp>
-        <p:nvSpPr>
-          <p:cNvPr id="28" name="Rectangle 27"/>
-          <p:cNvSpPr/>
-          <p:nvPr/>
-        </p:nvSpPr>
-        <p:spPr>
-          <a:xfrm>
-            <a:off x="5303520" y="4526280"/>
-            <a:ext cx="1463040" cy="1554480"/>
-          </a:xfrm>
-          <a:prstGeom prst="rect">
-            <a:avLst/>
-          </a:prstGeom>
-          <a:solidFill>
-            <a:srgbClr val="2E2E4E"/>
-          </a:solidFill>
-          <a:ln>
-            <a:noFill/>
-          </a:ln>
-          <a:effectLst/>
-        </p:spPr>
-        <p:style>
-          <a:lnRef idx="1">
-            <a:schemeClr val="accent1"/>
-          </a:lnRef>
-          <a:fillRef idx="3">
-            <a:schemeClr val="accent1"/>
-          </a:fillRef>
-          <a:effectRef idx="2">
-            <a:schemeClr val="accent1"/>
-          </a:effectRef>
-          <a:fontRef idx="minor">
-            <a:schemeClr val="lt1"/>
-          </a:fontRef>
-        </p:style>
-        <p:txBody>
-          <a:bodyPr rtlCol="0" anchor="ctr"/>
-          <a:lstStyle/>
-          <a:p>
-            <a:pPr algn="ctr"/>
-          </a:p>
-        </p:txBody>
-      </p:sp>
-      <p:sp>
-        <p:nvSpPr>
-          <p:cNvPr id="29" name="TextBox 28"/>
-          <p:cNvSpPr txBox="1"/>
-          <p:nvPr/>
-        </p:nvSpPr>
-        <p:spPr>
-          <a:xfrm>
-            <a:off x="5394960" y="4617720"/>
-            <a:ext cx="1280160" cy="320040"/>
-          </a:xfrm>
-          <a:prstGeom prst="rect">
-            <a:avLst/>
-          </a:prstGeom>
-          <a:noFill/>
-        </p:spPr>
-        <p:txBody>
-          <a:bodyPr wrap="square">
-            <a:spAutoFit/>
-          </a:bodyPr>
-          <a:lstStyle/>
-          <a:p>
-            <a:pPr algn="ctr">
-              <a:defRPr sz="1300" b="1">
-                <a:solidFill>
-                  <a:srgbClr val="00D2FF"/>
-                </a:solidFill>
-              </a:defRPr>
-            </a:pPr>
-            <a:r>
-              <a:t>Hooks</a:t>
-            </a:r>
-          </a:p>
-        </p:txBody>
-      </p:sp>
-      <p:sp>
-        <p:nvSpPr>
-          <p:cNvPr id="30" name="TextBox 29"/>
-          <p:cNvSpPr txBox="1"/>
-          <p:nvPr/>
-        </p:nvSpPr>
-        <p:spPr>
-          <a:xfrm>
-            <a:off x="5394960" y="4937760"/>
-            <a:ext cx="1280160" cy="320040"/>
-          </a:xfrm>
-          <a:prstGeom prst="rect">
-            <a:avLst/>
-          </a:prstGeom>
-          <a:noFill/>
-        </p:spPr>
-        <p:txBody>
-          <a:bodyPr wrap="square">
-            <a:spAutoFit/>
-          </a:bodyPr>
-          <a:lstStyle/>
-          <a:p>
-            <a:pPr algn="ctr">
-              <a:defRPr sz="900" b="0">
-                <a:solidFill>
-                  <a:srgbClr val="FF9F43"/>
-                </a:solidFill>
-              </a:defRPr>
-            </a:pPr>
-            <a:r>
-              <a:t>hooks.ts</a:t>
-            </a:r>
-          </a:p>
-        </p:txBody>
-      </p:sp>
-      <p:sp>
-        <p:nvSpPr>
-          <p:cNvPr id="31" name="TextBox 30"/>
-          <p:cNvSpPr txBox="1"/>
-          <p:nvPr/>
-        </p:nvSpPr>
-        <p:spPr>
-          <a:xfrm>
-            <a:off x="5394960" y="5303520"/>
-            <a:ext cx="1280160" cy="640080"/>
-          </a:xfrm>
-          <a:prstGeom prst="rect">
-            <a:avLst/>
-          </a:prstGeom>
-          <a:noFill/>
-        </p:spPr>
-        <p:txBody>
-          <a:bodyPr wrap="square">
-            <a:spAutoFit/>
-          </a:bodyPr>
-          <a:lstStyle/>
-          <a:p>
-            <a:pPr algn="ctr">
+                  <a:srgbClr val="444444"/>
+                </a:solidFill>
+                <a:latin typeface="Microsoft YaHei"/>
+              </a:defRPr>
+            </a:pPr>
+            <a:r>
+              <a:t>    &lt;sessionId&gt;/</a:t>
+            </a:r>
+          </a:p>
+          <a:p>
+            <a:pPr>
+              <a:spcBef>
+                <a:spcPts val="300"/>
+              </a:spcBef>
               <a:defRPr sz="1100" b="0">
                 <a:solidFill>
-                  <a:srgbClr val="CCCCDD"/>
-                </a:solidFill>
-              </a:defRPr>
-            </a:pPr>
-            <a:r>
-              <a:t>自动触发集成</a:t>
-            </a:r>
-          </a:p>
-        </p:txBody>
-      </p:sp>
-      <p:sp>
-        <p:nvSpPr>
-          <p:cNvPr id="32" name="Rectangle 31"/>
-          <p:cNvSpPr/>
-          <p:nvPr/>
-        </p:nvSpPr>
-        <p:spPr>
-          <a:xfrm>
-            <a:off x="6903720" y="4526280"/>
-            <a:ext cx="1463040" cy="1554480"/>
-          </a:xfrm>
-          <a:prstGeom prst="rect">
-            <a:avLst/>
-          </a:prstGeom>
-          <a:solidFill>
-            <a:srgbClr val="2E2E4E"/>
-          </a:solidFill>
-          <a:ln>
-            <a:noFill/>
-          </a:ln>
-          <a:effectLst/>
-        </p:spPr>
-        <p:style>
-          <a:lnRef idx="1">
-            <a:schemeClr val="accent1"/>
-          </a:lnRef>
-          <a:fillRef idx="3">
-            <a:schemeClr val="accent1"/>
-          </a:fillRef>
-          <a:effectRef idx="2">
-            <a:schemeClr val="accent1"/>
-          </a:effectRef>
-          <a:fontRef idx="minor">
-            <a:schemeClr val="lt1"/>
-          </a:fontRef>
-        </p:style>
-        <p:txBody>
-          <a:bodyPr rtlCol="0" anchor="ctr"/>
-          <a:lstStyle/>
-          <a:p>
-            <a:pPr algn="ctr"/>
-          </a:p>
-        </p:txBody>
-      </p:sp>
-      <p:sp>
-        <p:nvSpPr>
-          <p:cNvPr id="33" name="TextBox 32"/>
-          <p:cNvSpPr txBox="1"/>
-          <p:nvPr/>
-        </p:nvSpPr>
-        <p:spPr>
-          <a:xfrm>
-            <a:off x="6995160" y="4617720"/>
-            <a:ext cx="1280160" cy="320040"/>
-          </a:xfrm>
-          <a:prstGeom prst="rect">
-            <a:avLst/>
-          </a:prstGeom>
-          <a:noFill/>
-        </p:spPr>
-        <p:txBody>
-          <a:bodyPr wrap="square">
-            <a:spAutoFit/>
-          </a:bodyPr>
-          <a:lstStyle/>
-          <a:p>
-            <a:pPr algn="ctr">
-              <a:defRPr sz="1300" b="1">
-                <a:solidFill>
-                  <a:srgbClr val="00D2FF"/>
-                </a:solidFill>
-              </a:defRPr>
-            </a:pPr>
-            <a:r>
-              <a:t>HTTP API</a:t>
-            </a:r>
-          </a:p>
-        </p:txBody>
-      </p:sp>
-      <p:sp>
-        <p:nvSpPr>
-          <p:cNvPr id="34" name="TextBox 33"/>
-          <p:cNvSpPr txBox="1"/>
-          <p:nvPr/>
-        </p:nvSpPr>
-        <p:spPr>
-          <a:xfrm>
-            <a:off x="6995160" y="4937760"/>
-            <a:ext cx="1280160" cy="320040"/>
-          </a:xfrm>
-          <a:prstGeom prst="rect">
-            <a:avLst/>
-          </a:prstGeom>
-          <a:noFill/>
-        </p:spPr>
-        <p:txBody>
-          <a:bodyPr wrap="square">
-            <a:spAutoFit/>
-          </a:bodyPr>
-          <a:lstStyle/>
-          <a:p>
-            <a:pPr algn="ctr">
-              <a:defRPr sz="900" b="0">
-                <a:solidFill>
-                  <a:srgbClr val="FF9F43"/>
-                </a:solidFill>
-              </a:defRPr>
-            </a:pPr>
-            <a:r>
-              <a:t>http.ts</a:t>
-            </a:r>
-          </a:p>
-        </p:txBody>
-      </p:sp>
-      <p:sp>
-        <p:nvSpPr>
-          <p:cNvPr id="35" name="TextBox 34"/>
-          <p:cNvSpPr txBox="1"/>
-          <p:nvPr/>
-        </p:nvSpPr>
-        <p:spPr>
-          <a:xfrm>
-            <a:off x="6995160" y="5303520"/>
-            <a:ext cx="1280160" cy="640080"/>
-          </a:xfrm>
-          <a:prstGeom prst="rect">
-            <a:avLst/>
-          </a:prstGeom>
-          <a:noFill/>
-        </p:spPr>
-        <p:txBody>
-          <a:bodyPr wrap="square">
-            <a:spAutoFit/>
-          </a:bodyPr>
-          <a:lstStyle/>
-          <a:p>
-            <a:pPr algn="ctr">
+                  <a:srgbClr val="444444"/>
+                </a:solidFill>
+                <a:latin typeface="Microsoft YaHei"/>
+              </a:defRPr>
+            </a:pPr>
+            <a:r>
+              <a:t>      manifest.json       有序列表+currentHead</a:t>
+            </a:r>
+          </a:p>
+          <a:p>
+            <a:pPr>
+              <a:spcBef>
+                <a:spcPts val="300"/>
+              </a:spcBef>
               <a:defRPr sz="1100" b="0">
                 <a:solidFill>
-                  <a:srgbClr val="CCCCDD"/>
-                </a:solidFill>
-              </a:defRPr>
-            </a:pPr>
-            <a:r>
-              <a:t>REST 端点</a:t>
-            </a:r>
-          </a:p>
-        </p:txBody>
-      </p:sp>
-      <p:sp>
-        <p:nvSpPr>
-          <p:cNvPr id="36" name="Rectangle 35"/>
-          <p:cNvSpPr/>
-          <p:nvPr/>
-        </p:nvSpPr>
-        <p:spPr>
-          <a:xfrm>
-            <a:off x="8503920" y="4526280"/>
-            <a:ext cx="1463040" cy="1554480"/>
-          </a:xfrm>
-          <a:prstGeom prst="rect">
-            <a:avLst/>
-          </a:prstGeom>
-          <a:solidFill>
-            <a:srgbClr val="2E2E4E"/>
-          </a:solidFill>
-          <a:ln>
-            <a:noFill/>
-          </a:ln>
-          <a:effectLst/>
-        </p:spPr>
-        <p:style>
-          <a:lnRef idx="1">
-            <a:schemeClr val="accent1"/>
-          </a:lnRef>
-          <a:fillRef idx="3">
-            <a:schemeClr val="accent1"/>
-          </a:fillRef>
-          <a:effectRef idx="2">
-            <a:schemeClr val="accent1"/>
-          </a:effectRef>
-          <a:fontRef idx="minor">
-            <a:schemeClr val="lt1"/>
-          </a:fontRef>
-        </p:style>
-        <p:txBody>
-          <a:bodyPr rtlCol="0" anchor="ctr"/>
-          <a:lstStyle/>
-          <a:p>
-            <a:pPr algn="ctr"/>
-          </a:p>
-        </p:txBody>
-      </p:sp>
-      <p:sp>
-        <p:nvSpPr>
-          <p:cNvPr id="37" name="TextBox 36"/>
-          <p:cNvSpPr txBox="1"/>
-          <p:nvPr/>
-        </p:nvSpPr>
-        <p:spPr>
-          <a:xfrm>
-            <a:off x="8595360" y="4617720"/>
-            <a:ext cx="1280160" cy="320040"/>
-          </a:xfrm>
-          <a:prstGeom prst="rect">
-            <a:avLst/>
-          </a:prstGeom>
-          <a:noFill/>
-        </p:spPr>
-        <p:txBody>
-          <a:bodyPr wrap="square">
-            <a:spAutoFit/>
-          </a:bodyPr>
-          <a:lstStyle/>
-          <a:p>
-            <a:pPr algn="ctr">
-              <a:defRPr sz="1300" b="1">
-                <a:solidFill>
-                  <a:srgbClr val="00D2FF"/>
-                </a:solidFill>
-              </a:defRPr>
-            </a:pPr>
-            <a:r>
-              <a:t>Tool</a:t>
-            </a:r>
-          </a:p>
-        </p:txBody>
-      </p:sp>
-      <p:sp>
-        <p:nvSpPr>
-          <p:cNvPr id="38" name="TextBox 37"/>
-          <p:cNvSpPr txBox="1"/>
-          <p:nvPr/>
-        </p:nvSpPr>
-        <p:spPr>
-          <a:xfrm>
-            <a:off x="8595360" y="4937760"/>
-            <a:ext cx="1280160" cy="320040"/>
-          </a:xfrm>
-          <a:prstGeom prst="rect">
-            <a:avLst/>
-          </a:prstGeom>
-          <a:noFill/>
-        </p:spPr>
-        <p:txBody>
-          <a:bodyPr wrap="square">
-            <a:spAutoFit/>
-          </a:bodyPr>
-          <a:lstStyle/>
-          <a:p>
-            <a:pPr algn="ctr">
-              <a:defRPr sz="900" b="0">
-                <a:solidFill>
-                  <a:srgbClr val="FF9F43"/>
-                </a:solidFill>
-              </a:defRPr>
-            </a:pPr>
-            <a:r>
-              <a:t>tool.ts</a:t>
-            </a:r>
-          </a:p>
-        </p:txBody>
-      </p:sp>
-      <p:sp>
-        <p:nvSpPr>
-          <p:cNvPr id="39" name="TextBox 38"/>
-          <p:cNvSpPr txBox="1"/>
-          <p:nvPr/>
-        </p:nvSpPr>
-        <p:spPr>
-          <a:xfrm>
-            <a:off x="8595360" y="5303520"/>
-            <a:ext cx="1280160" cy="640080"/>
-          </a:xfrm>
-          <a:prstGeom prst="rect">
-            <a:avLst/>
-          </a:prstGeom>
-          <a:noFill/>
-        </p:spPr>
-        <p:txBody>
-          <a:bodyPr wrap="square">
-            <a:spAutoFit/>
-          </a:bodyPr>
-          <a:lstStyle/>
-          <a:p>
-            <a:pPr algn="ctr">
+                  <a:srgbClr val="444444"/>
+                </a:solidFill>
+                <a:latin typeface="Microsoft YaHei"/>
+              </a:defRPr>
+            </a:pPr>
+            <a:r>
+              <a:t>      &lt;checkpointId&gt;/</a:t>
+            </a:r>
+          </a:p>
+          <a:p>
+            <a:pPr>
+              <a:spcBef>
+                <a:spcPts val="300"/>
+              </a:spcBef>
               <a:defRPr sz="1100" b="0">
                 <a:solidFill>
-                  <a:srgbClr val="CCCCDD"/>
-                </a:solidFill>
-              </a:defRPr>
-            </a:pPr>
-            <a:r>
-              <a:t>Agent 工具接口</a:t>
-            </a:r>
-          </a:p>
-        </p:txBody>
-      </p:sp>
-      <p:sp>
-        <p:nvSpPr>
-          <p:cNvPr id="40" name="Rectangle 39"/>
-          <p:cNvSpPr/>
-          <p:nvPr/>
-        </p:nvSpPr>
-        <p:spPr>
-          <a:xfrm>
-            <a:off x="10104120" y="4526280"/>
-            <a:ext cx="1463040" cy="1554480"/>
-          </a:xfrm>
-          <a:prstGeom prst="rect">
-            <a:avLst/>
-          </a:prstGeom>
-          <a:solidFill>
-            <a:srgbClr val="2E2E4E"/>
-          </a:solidFill>
-          <a:ln>
-            <a:noFill/>
-          </a:ln>
-          <a:effectLst/>
-        </p:spPr>
-        <p:style>
-          <a:lnRef idx="1">
-            <a:schemeClr val="accent1"/>
-          </a:lnRef>
-          <a:fillRef idx="3">
-            <a:schemeClr val="accent1"/>
-          </a:fillRef>
-          <a:effectRef idx="2">
-            <a:schemeClr val="accent1"/>
-          </a:effectRef>
-          <a:fontRef idx="minor">
-            <a:schemeClr val="lt1"/>
-          </a:fontRef>
-        </p:style>
-        <p:txBody>
-          <a:bodyPr rtlCol="0" anchor="ctr"/>
-          <a:lstStyle/>
-          <a:p>
-            <a:pPr algn="ctr"/>
-          </a:p>
-        </p:txBody>
-      </p:sp>
-      <p:sp>
-        <p:nvSpPr>
-          <p:cNvPr id="41" name="TextBox 40"/>
-          <p:cNvSpPr txBox="1"/>
-          <p:nvPr/>
-        </p:nvSpPr>
-        <p:spPr>
-          <a:xfrm>
-            <a:off x="10195560" y="4617720"/>
-            <a:ext cx="1280160" cy="320040"/>
-          </a:xfrm>
-          <a:prstGeom prst="rect">
-            <a:avLst/>
-          </a:prstGeom>
-          <a:noFill/>
-        </p:spPr>
-        <p:txBody>
-          <a:bodyPr wrap="square">
-            <a:spAutoFit/>
-          </a:bodyPr>
-          <a:lstStyle/>
-          <a:p>
-            <a:pPr algn="ctr">
-              <a:defRPr sz="1300" b="1">
-                <a:solidFill>
-                  <a:srgbClr val="00D2FF"/>
-                </a:solidFill>
-              </a:defRPr>
-            </a:pPr>
-            <a:r>
-              <a:t>Viewer</a:t>
-            </a:r>
-          </a:p>
-        </p:txBody>
-      </p:sp>
-      <p:sp>
-        <p:nvSpPr>
-          <p:cNvPr id="42" name="TextBox 41"/>
-          <p:cNvSpPr txBox="1"/>
-          <p:nvPr/>
-        </p:nvSpPr>
-        <p:spPr>
-          <a:xfrm>
-            <a:off x="10195560" y="4937760"/>
-            <a:ext cx="1280160" cy="320040"/>
-          </a:xfrm>
-          <a:prstGeom prst="rect">
-            <a:avLst/>
-          </a:prstGeom>
-          <a:noFill/>
-        </p:spPr>
-        <p:txBody>
-          <a:bodyPr wrap="square">
-            <a:spAutoFit/>
-          </a:bodyPr>
-          <a:lstStyle/>
-          <a:p>
-            <a:pPr algn="ctr">
-              <a:defRPr sz="900" b="0">
-                <a:solidFill>
-                  <a:srgbClr val="FF9F43"/>
-                </a:solidFill>
-              </a:defRPr>
-            </a:pPr>
-            <a:r>
-              <a:t>viewer/</a:t>
-            </a:r>
-          </a:p>
-        </p:txBody>
-      </p:sp>
-      <p:sp>
-        <p:nvSpPr>
-          <p:cNvPr id="43" name="TextBox 42"/>
-          <p:cNvSpPr txBox="1"/>
-          <p:nvPr/>
-        </p:nvSpPr>
-        <p:spPr>
-          <a:xfrm>
-            <a:off x="10195560" y="5303520"/>
-            <a:ext cx="1280160" cy="640080"/>
-          </a:xfrm>
-          <a:prstGeom prst="rect">
-            <a:avLst/>
-          </a:prstGeom>
-          <a:noFill/>
-        </p:spPr>
-        <p:txBody>
-          <a:bodyPr wrap="square">
-            <a:spAutoFit/>
-          </a:bodyPr>
-          <a:lstStyle/>
-          <a:p>
-            <a:pPr algn="ctr">
-              <a:defRPr sz="1100" b="0">
-                <a:solidFill>
-                  <a:srgbClr val="CCCCDD"/>
-                </a:solidFill>
-              </a:defRPr>
-            </a:pPr>
-            <a:r>
-              <a:t>时间线可视化</a:t>
-            </a:r>
-          </a:p>
-        </p:txBody>
-      </p:sp>
-      <p:sp>
-        <p:nvSpPr>
-          <p:cNvPr id="44" name="Can 43"/>
-          <p:cNvSpPr/>
-          <p:nvPr/>
-        </p:nvSpPr>
-        <p:spPr>
-          <a:xfrm>
-            <a:off x="1920240" y="5166360"/>
-            <a:ext cx="228600" cy="228600"/>
-          </a:xfrm>
-          <a:prstGeom prst="can">
-            <a:avLst/>
-          </a:prstGeom>
-          <a:solidFill>
-            <a:srgbClr val="7B61FF"/>
-          </a:solidFill>
-          <a:ln>
-            <a:noFill/>
-          </a:ln>
-        </p:spPr>
-        <p:style>
-          <a:lnRef idx="1">
-            <a:schemeClr val="accent1"/>
-          </a:lnRef>
-          <a:fillRef idx="3">
-            <a:schemeClr val="accent1"/>
-          </a:fillRef>
-          <a:effectRef idx="2">
-            <a:schemeClr val="accent1"/>
-          </a:effectRef>
-          <a:fontRef idx="minor">
-            <a:schemeClr val="lt1"/>
-          </a:fontRef>
-        </p:style>
-        <p:txBody>
-          <a:bodyPr rtlCol="0" anchor="ctr"/>
-          <a:lstStyle/>
-          <a:p>
-            <a:pPr algn="ctr"/>
-          </a:p>
-        </p:txBody>
-      </p:sp>
-      <p:sp>
-        <p:nvSpPr>
-          <p:cNvPr id="45" name="Can 44"/>
-          <p:cNvSpPr/>
-          <p:nvPr/>
-        </p:nvSpPr>
-        <p:spPr>
-          <a:xfrm>
-            <a:off x="3520440" y="5166360"/>
-            <a:ext cx="228600" cy="228600"/>
-          </a:xfrm>
-          <a:prstGeom prst="can">
-            <a:avLst/>
-          </a:prstGeom>
-          <a:solidFill>
-            <a:srgbClr val="7B61FF"/>
-          </a:solidFill>
-          <a:ln>
-            <a:noFill/>
-          </a:ln>
-        </p:spPr>
-        <p:style>
-          <a:lnRef idx="1">
-            <a:schemeClr val="accent1"/>
-          </a:lnRef>
-          <a:fillRef idx="3">
-            <a:schemeClr val="accent1"/>
-          </a:fillRef>
-          <a:effectRef idx="2">
-            <a:schemeClr val="accent1"/>
-          </a:effectRef>
-          <a:fontRef idx="minor">
-            <a:schemeClr val="lt1"/>
-          </a:fontRef>
-        </p:style>
-        <p:txBody>
-          <a:bodyPr rtlCol="0" anchor="ctr"/>
-          <a:lstStyle/>
-          <a:p>
-            <a:pPr algn="ctr"/>
-          </a:p>
-        </p:txBody>
-      </p:sp>
-      <p:sp>
-        <p:nvSpPr>
-          <p:cNvPr id="46" name="Can 45"/>
-          <p:cNvSpPr/>
-          <p:nvPr/>
-        </p:nvSpPr>
-        <p:spPr>
-          <a:xfrm>
-            <a:off x="5120640" y="5166360"/>
-            <a:ext cx="228600" cy="228600"/>
-          </a:xfrm>
-          <a:prstGeom prst="can">
-            <a:avLst/>
-          </a:prstGeom>
-          <a:solidFill>
-            <a:srgbClr val="7B61FF"/>
-          </a:solidFill>
-          <a:ln>
-            <a:noFill/>
-          </a:ln>
-        </p:spPr>
-        <p:style>
-          <a:lnRef idx="1">
-            <a:schemeClr val="accent1"/>
-          </a:lnRef>
-          <a:fillRef idx="3">
-            <a:schemeClr val="accent1"/>
-          </a:fillRef>
-          <a:effectRef idx="2">
-            <a:schemeClr val="accent1"/>
-          </a:effectRef>
-          <a:fontRef idx="minor">
-            <a:schemeClr val="lt1"/>
-          </a:fontRef>
-        </p:style>
-        <p:txBody>
-          <a:bodyPr rtlCol="0" anchor="ctr"/>
-          <a:lstStyle/>
-          <a:p>
-            <a:pPr algn="ctr"/>
-          </a:p>
-        </p:txBody>
-      </p:sp>
-      <p:sp>
-        <p:nvSpPr>
-          <p:cNvPr id="47" name="Can 46"/>
-          <p:cNvSpPr/>
-          <p:nvPr/>
-        </p:nvSpPr>
-        <p:spPr>
-          <a:xfrm>
-            <a:off x="6720840" y="5166360"/>
-            <a:ext cx="228600" cy="228600"/>
-          </a:xfrm>
-          <a:prstGeom prst="can">
-            <a:avLst/>
-          </a:prstGeom>
-          <a:solidFill>
-            <a:srgbClr val="7B61FF"/>
-          </a:solidFill>
-          <a:ln>
-            <a:noFill/>
-          </a:ln>
-        </p:spPr>
-        <p:style>
-          <a:lnRef idx="1">
-            <a:schemeClr val="accent1"/>
-          </a:lnRef>
-          <a:fillRef idx="3">
-            <a:schemeClr val="accent1"/>
-          </a:fillRef>
-          <a:effectRef idx="2">
-            <a:schemeClr val="accent1"/>
-          </a:effectRef>
-          <a:fontRef idx="minor">
-            <a:schemeClr val="lt1"/>
-          </a:fontRef>
-        </p:style>
-        <p:txBody>
-          <a:bodyPr rtlCol="0" anchor="ctr"/>
-          <a:lstStyle/>
-          <a:p>
-            <a:pPr algn="ctr"/>
-          </a:p>
-        </p:txBody>
-      </p:sp>
-      <p:sp>
-        <p:nvSpPr>
-          <p:cNvPr id="48" name="Can 47"/>
-          <p:cNvSpPr/>
-          <p:nvPr/>
-        </p:nvSpPr>
-        <p:spPr>
-          <a:xfrm>
-            <a:off x="8321040" y="5166360"/>
-            <a:ext cx="228600" cy="228600"/>
-          </a:xfrm>
-          <a:prstGeom prst="can">
-            <a:avLst/>
-          </a:prstGeom>
-          <a:solidFill>
-            <a:srgbClr val="7B61FF"/>
-          </a:solidFill>
-          <a:ln>
-            <a:noFill/>
-          </a:ln>
-        </p:spPr>
-        <p:style>
-          <a:lnRef idx="1">
-            <a:schemeClr val="accent1"/>
-          </a:lnRef>
-          <a:fillRef idx="3">
-            <a:schemeClr val="accent1"/>
-          </a:fillRef>
-          <a:effectRef idx="2">
-            <a:schemeClr val="accent1"/>
-          </a:effectRef>
-          <a:fontRef idx="minor">
-            <a:schemeClr val="lt1"/>
-          </a:fontRef>
-        </p:style>
-        <p:txBody>
-          <a:bodyPr rtlCol="0" anchor="ctr"/>
-          <a:lstStyle/>
-          <a:p>
-            <a:pPr algn="ctr"/>
-          </a:p>
-        </p:txBody>
-      </p:sp>
-      <p:sp>
-        <p:nvSpPr>
-          <p:cNvPr id="49" name="Can 48"/>
-          <p:cNvSpPr/>
-          <p:nvPr/>
-        </p:nvSpPr>
-        <p:spPr>
-          <a:xfrm>
-            <a:off x="9921240" y="5166360"/>
-            <a:ext cx="228600" cy="228600"/>
-          </a:xfrm>
-          <a:prstGeom prst="can">
-            <a:avLst/>
-          </a:prstGeom>
-          <a:solidFill>
-            <a:srgbClr val="7B61FF"/>
-          </a:solidFill>
-          <a:ln>
-            <a:noFill/>
-          </a:ln>
-        </p:spPr>
-        <p:style>
-          <a:lnRef idx="1">
-            <a:schemeClr val="accent1"/>
-          </a:lnRef>
-          <a:fillRef idx="3">
-            <a:schemeClr val="accent1"/>
-          </a:fillRef>
-          <a:effectRef idx="2">
-            <a:schemeClr val="accent1"/>
-          </a:effectRef>
-          <a:fontRef idx="minor">
-            <a:schemeClr val="lt1"/>
-          </a:fontRef>
-        </p:style>
-        <p:txBody>
-          <a:bodyPr rtlCol="0" anchor="ctr"/>
-          <a:lstStyle/>
-          <a:p>
-            <a:pPr algn="ctr"/>
-          </a:p>
-        </p:txBody>
-      </p:sp>
-      <p:sp>
-        <p:nvSpPr>
-          <p:cNvPr id="50" name="TextBox 49"/>
-          <p:cNvSpPr txBox="1"/>
-          <p:nvPr/>
-        </p:nvSpPr>
-        <p:spPr>
-          <a:xfrm>
-            <a:off x="548640" y="6446520"/>
-            <a:ext cx="10972800" cy="320040"/>
-          </a:xfrm>
-          <a:prstGeom prst="rect">
-            <a:avLst/>
-          </a:prstGeom>
-          <a:noFill/>
-        </p:spPr>
-        <p:txBody>
-          <a:bodyPr wrap="square">
-            <a:spAutoFit/>
-          </a:bodyPr>
-          <a:lstStyle/>
-          <a:p>
-            <a:pPr algn="l">
-              <a:defRPr sz="1000" b="0">
-                <a:solidFill>
-                  <a:srgbClr val="8888AA"/>
-                </a:solidFill>
-              </a:defRPr>
-            </a:pPr>
-            <a:r>
-              <a:t>存储结构:  &lt;storagePath&gt;/&lt;agentId&gt;/&lt;sessionId&gt;/manifest.json + &lt;checkpointId&gt;/meta.json          触发模式:  after_tool_call | session_start | manual          排除工具:  read, glob, grep, memory_search, memory_get</a:t>
+                  <a:srgbClr val="444444"/>
+                </a:solidFill>
+                <a:latin typeface="Microsoft YaHei"/>
+              </a:defRPr>
+            </a:pPr>
+            <a:r>
+              <a:t>        meta.json         完整元数据</a:t>
+            </a:r>
+          </a:p>
+          <a:p>
+            <a:pPr>
+              <a:spcBef>
+                <a:spcPts val="300"/>
+              </a:spcBef>
+              <a:defRPr sz="600" b="0">
+                <a:solidFill>
+                  <a:srgbClr val="222222"/>
+                </a:solidFill>
+                <a:latin typeface="Microsoft YaHei"/>
+              </a:defRPr>
+            </a:pPr>
+          </a:p>
+          <a:p>
+            <a:pPr>
+              <a:spcBef>
+                <a:spcPts val="300"/>
+              </a:spcBef>
+              <a:defRPr sz="1200" b="1">
+                <a:solidFill>
+                  <a:srgbClr val="444444"/>
+                </a:solidFill>
+                <a:latin typeface="Microsoft YaHei"/>
+              </a:defRPr>
+            </a:pPr>
+            <a:r>
+              <a:t>meta.json 包含</a:t>
+            </a:r>
+          </a:p>
+          <a:p>
+            <a:pPr>
+              <a:spcBef>
+                <a:spcPts val="300"/>
+              </a:spcBef>
+              <a:defRPr sz="1200" b="0">
+                <a:solidFill>
+                  <a:srgbClr val="222222"/>
+                </a:solidFill>
+                <a:latin typeface="Microsoft YaHei"/>
+              </a:defRPr>
+            </a:pPr>
+            <a:r>
+              <a:t>ID、触发信息、commitSha、treeSha、</a:t>
+            </a:r>
+          </a:p>
+          <a:p>
+            <a:pPr>
+              <a:spcBef>
+                <a:spcPts val="300"/>
+              </a:spcBef>
+              <a:defRPr sz="1200" b="0">
+                <a:solidFill>
+                  <a:srgbClr val="222222"/>
+                </a:solidFill>
+                <a:latin typeface="Microsoft YaHei"/>
+              </a:defRPr>
+            </a:pPr>
+            <a:r>
+              <a:t>变更文件列表、JSONL 字节偏移、时间戳</a:t>
+            </a:r>
+          </a:p>
+          <a:p>
+            <a:pPr>
+              <a:spcBef>
+                <a:spcPts val="300"/>
+              </a:spcBef>
+              <a:defRPr sz="600" b="0">
+                <a:solidFill>
+                  <a:srgbClr val="222222"/>
+                </a:solidFill>
+                <a:latin typeface="Microsoft YaHei"/>
+              </a:defRPr>
+            </a:pPr>
+          </a:p>
+          <a:p>
+            <a:pPr>
+              <a:spcBef>
+                <a:spcPts val="300"/>
+              </a:spcBef>
+              <a:defRPr sz="1200" b="1">
+                <a:solidFill>
+                  <a:srgbClr val="444444"/>
+                </a:solidFill>
+                <a:latin typeface="Microsoft YaHei"/>
+              </a:defRPr>
+            </a:pPr>
+            <a:r>
+              <a:t>清理策略</a:t>
+            </a:r>
+          </a:p>
+          <a:p>
+            <a:pPr>
+              <a:spcBef>
+                <a:spcPts val="300"/>
+              </a:spcBef>
+              <a:defRPr sz="1200" b="0">
+                <a:solidFill>
+                  <a:srgbClr val="222222"/>
+                </a:solidFill>
+                <a:latin typeface="Microsoft YaHei"/>
+              </a:defRPr>
+            </a:pPr>
+            <a:r>
+              <a:t>每 session 上限 200 个 checkpoint</a:t>
+            </a:r>
+          </a:p>
+          <a:p>
+            <a:pPr>
+              <a:spcBef>
+                <a:spcPts val="300"/>
+              </a:spcBef>
+              <a:defRPr sz="1200" b="0">
+                <a:solidFill>
+                  <a:srgbClr val="222222"/>
+                </a:solidFill>
+                <a:latin typeface="Microsoft YaHei"/>
+              </a:defRPr>
+            </a:pPr>
+            <a:r>
+              <a:t>全局保留期 30 天，超期自动删除</a:t>
             </a:r>
           </a:p>
         </p:txBody>

</xml_diff>